<commit_message>
1064-nm comparison (dT and R)
</commit_message>
<xml_diff>
--- a/meetings/Meeting PP.pptx
+++ b/meetings/Meeting PP.pptx
@@ -28,6 +28,9 @@
     <p:sldId id="306" r:id="rId22"/>
     <p:sldId id="307" r:id="rId23"/>
     <p:sldId id="308" r:id="rId24"/>
+    <p:sldId id="313" r:id="rId25"/>
+    <p:sldId id="311" r:id="rId26"/>
+    <p:sldId id="312" r:id="rId27"/>
   </p:sldIdLst>
   <p:sldSz cx="12192000" cy="6858000"/>
   <p:notesSz cx="6858000" cy="9144000"/>
@@ -283,7 +286,7 @@
           <a:p>
             <a:fld id="{AC95DD63-6668-4FD6-91E0-C37FAC7BA147}" type="datetimeFigureOut">
               <a:rPr lang="en-GB" smtClean="0"/>
-              <a:t>19/03/2026</a:t>
+              <a:t>18/05/2026</a:t>
             </a:fld>
             <a:endParaRPr lang="en-GB"/>
           </a:p>
@@ -483,7 +486,7 @@
           <a:p>
             <a:fld id="{AC95DD63-6668-4FD6-91E0-C37FAC7BA147}" type="datetimeFigureOut">
               <a:rPr lang="en-GB" smtClean="0"/>
-              <a:t>19/03/2026</a:t>
+              <a:t>18/05/2026</a:t>
             </a:fld>
             <a:endParaRPr lang="en-GB"/>
           </a:p>
@@ -693,7 +696,7 @@
           <a:p>
             <a:fld id="{AC95DD63-6668-4FD6-91E0-C37FAC7BA147}" type="datetimeFigureOut">
               <a:rPr lang="en-GB" smtClean="0"/>
-              <a:t>19/03/2026</a:t>
+              <a:t>18/05/2026</a:t>
             </a:fld>
             <a:endParaRPr lang="en-GB"/>
           </a:p>
@@ -893,7 +896,7 @@
           <a:p>
             <a:fld id="{AC95DD63-6668-4FD6-91E0-C37FAC7BA147}" type="datetimeFigureOut">
               <a:rPr lang="en-GB" smtClean="0"/>
-              <a:t>19/03/2026</a:t>
+              <a:t>18/05/2026</a:t>
             </a:fld>
             <a:endParaRPr lang="en-GB"/>
           </a:p>
@@ -1169,7 +1172,7 @@
           <a:p>
             <a:fld id="{AC95DD63-6668-4FD6-91E0-C37FAC7BA147}" type="datetimeFigureOut">
               <a:rPr lang="en-GB" smtClean="0"/>
-              <a:t>19/03/2026</a:t>
+              <a:t>18/05/2026</a:t>
             </a:fld>
             <a:endParaRPr lang="en-GB"/>
           </a:p>
@@ -1437,7 +1440,7 @@
           <a:p>
             <a:fld id="{AC95DD63-6668-4FD6-91E0-C37FAC7BA147}" type="datetimeFigureOut">
               <a:rPr lang="en-GB" smtClean="0"/>
-              <a:t>19/03/2026</a:t>
+              <a:t>18/05/2026</a:t>
             </a:fld>
             <a:endParaRPr lang="en-GB"/>
           </a:p>
@@ -1852,7 +1855,7 @@
           <a:p>
             <a:fld id="{AC95DD63-6668-4FD6-91E0-C37FAC7BA147}" type="datetimeFigureOut">
               <a:rPr lang="en-GB" smtClean="0"/>
-              <a:t>19/03/2026</a:t>
+              <a:t>18/05/2026</a:t>
             </a:fld>
             <a:endParaRPr lang="en-GB"/>
           </a:p>
@@ -1994,7 +1997,7 @@
           <a:p>
             <a:fld id="{AC95DD63-6668-4FD6-91E0-C37FAC7BA147}" type="datetimeFigureOut">
               <a:rPr lang="en-GB" smtClean="0"/>
-              <a:t>19/03/2026</a:t>
+              <a:t>18/05/2026</a:t>
             </a:fld>
             <a:endParaRPr lang="en-GB"/>
           </a:p>
@@ -2107,7 +2110,7 @@
           <a:p>
             <a:fld id="{AC95DD63-6668-4FD6-91E0-C37FAC7BA147}" type="datetimeFigureOut">
               <a:rPr lang="en-GB" smtClean="0"/>
-              <a:t>19/03/2026</a:t>
+              <a:t>18/05/2026</a:t>
             </a:fld>
             <a:endParaRPr lang="en-GB"/>
           </a:p>
@@ -2420,7 +2423,7 @@
           <a:p>
             <a:fld id="{AC95DD63-6668-4FD6-91E0-C37FAC7BA147}" type="datetimeFigureOut">
               <a:rPr lang="en-GB" smtClean="0"/>
-              <a:t>19/03/2026</a:t>
+              <a:t>18/05/2026</a:t>
             </a:fld>
             <a:endParaRPr lang="en-GB"/>
           </a:p>
@@ -2709,7 +2712,7 @@
           <a:p>
             <a:fld id="{AC95DD63-6668-4FD6-91E0-C37FAC7BA147}" type="datetimeFigureOut">
               <a:rPr lang="en-GB" smtClean="0"/>
-              <a:t>19/03/2026</a:t>
+              <a:t>18/05/2026</a:t>
             </a:fld>
             <a:endParaRPr lang="en-GB"/>
           </a:p>
@@ -2952,7 +2955,7 @@
           <a:p>
             <a:fld id="{AC95DD63-6668-4FD6-91E0-C37FAC7BA147}" type="datetimeFigureOut">
               <a:rPr lang="en-GB" smtClean="0"/>
-              <a:t>19/03/2026</a:t>
+              <a:t>18/05/2026</a:t>
             </a:fld>
             <a:endParaRPr lang="en-GB"/>
           </a:p>
@@ -7751,6 +7754,3211 @@
     <p:extLst>
       <p:ext uri="{BB962C8B-B14F-4D97-AF65-F5344CB8AC3E}">
         <p14:creationId xmlns:p14="http://schemas.microsoft.com/office/powerpoint/2010/main" val="3136491668"/>
+      </p:ext>
+    </p:extLst>
+  </p:cSld>
+  <p:clrMapOvr>
+    <a:masterClrMapping/>
+  </p:clrMapOvr>
+</p:sld>
+</file>
+
+<file path=ppt/slides/slide24.xml><?xml version="1.0" encoding="utf-8"?>
+<p:sld xmlns:a="http://schemas.openxmlformats.org/drawingml/2006/main" xmlns:r="http://schemas.openxmlformats.org/officeDocument/2006/relationships" xmlns:p="http://schemas.openxmlformats.org/presentationml/2006/main">
+  <p:cSld>
+    <p:spTree>
+      <p:nvGrpSpPr>
+        <p:cNvPr id="1" name="">
+          <a:extLst>
+            <a:ext uri="{FF2B5EF4-FFF2-40B4-BE49-F238E27FC236}">
+              <a16:creationId xmlns:a16="http://schemas.microsoft.com/office/drawing/2014/main" id="{6EAA4C81-CD3A-83FE-42AC-C400FAEEDF2D}"/>
+            </a:ext>
+          </a:extLst>
+        </p:cNvPr>
+        <p:cNvGrpSpPr/>
+        <p:nvPr/>
+      </p:nvGrpSpPr>
+      <p:grpSpPr>
+        <a:xfrm>
+          <a:off x="0" y="0"/>
+          <a:ext cx="0" cy="0"/>
+          <a:chOff x="0" y="0"/>
+          <a:chExt cx="0" cy="0"/>
+        </a:xfrm>
+      </p:grpSpPr>
+      <p:sp>
+        <p:nvSpPr>
+          <p:cNvPr id="2" name="Title 1">
+            <a:extLst>
+              <a:ext uri="{FF2B5EF4-FFF2-40B4-BE49-F238E27FC236}">
+                <a16:creationId xmlns:a16="http://schemas.microsoft.com/office/drawing/2014/main" id="{CFB3E4E6-625F-FCE8-6CF1-B012145D8AD0}"/>
+              </a:ext>
+            </a:extLst>
+          </p:cNvPr>
+          <p:cNvSpPr>
+            <a:spLocks noGrp="1"/>
+          </p:cNvSpPr>
+          <p:nvPr>
+            <p:ph type="title"/>
+          </p:nvPr>
+        </p:nvSpPr>
+        <p:spPr>
+          <a:xfrm>
+            <a:off x="242978" y="365126"/>
+            <a:ext cx="5588479" cy="892774"/>
+          </a:xfrm>
+          <a:solidFill>
+            <a:srgbClr val="C00000"/>
+          </a:solidFill>
+        </p:spPr>
+        <p:txBody>
+          <a:bodyPr/>
+          <a:lstStyle/>
+          <a:p>
+            <a:r>
+              <a:rPr lang="en-US" dirty="0"/>
+              <a:t>1064 nm Optical limiter</a:t>
+            </a:r>
+            <a:endParaRPr lang="en-GB" dirty="0"/>
+          </a:p>
+        </p:txBody>
+      </p:sp>
+      <p:sp>
+        <p:nvSpPr>
+          <p:cNvPr id="5" name="Rectangle 4">
+            <a:extLst>
+              <a:ext uri="{FF2B5EF4-FFF2-40B4-BE49-F238E27FC236}">
+                <a16:creationId xmlns:a16="http://schemas.microsoft.com/office/drawing/2014/main" id="{A16A4907-50C4-042B-289D-DCE5099F65E1}"/>
+              </a:ext>
+            </a:extLst>
+          </p:cNvPr>
+          <p:cNvSpPr/>
+          <p:nvPr/>
+        </p:nvSpPr>
+        <p:spPr>
+          <a:xfrm>
+            <a:off x="242978" y="3950898"/>
+            <a:ext cx="2574000" cy="2880000"/>
+          </a:xfrm>
+          <a:prstGeom prst="rect">
+            <a:avLst/>
+          </a:prstGeom>
+        </p:spPr>
+        <p:style>
+          <a:lnRef idx="2">
+            <a:schemeClr val="accent1">
+              <a:shade val="15000"/>
+            </a:schemeClr>
+          </a:lnRef>
+          <a:fillRef idx="1">
+            <a:schemeClr val="accent1"/>
+          </a:fillRef>
+          <a:effectRef idx="0">
+            <a:schemeClr val="accent1"/>
+          </a:effectRef>
+          <a:fontRef idx="minor">
+            <a:schemeClr val="lt1"/>
+          </a:fontRef>
+        </p:style>
+        <p:txBody>
+          <a:bodyPr rtlCol="0" anchor="ctr"/>
+          <a:lstStyle/>
+          <a:p>
+            <a:pPr algn="ctr"/>
+            <a:r>
+              <a:rPr lang="en-US" dirty="0"/>
+              <a:t>SiO2 = 3 mm</a:t>
+            </a:r>
+            <a:endParaRPr lang="en-GB" dirty="0"/>
+          </a:p>
+        </p:txBody>
+      </p:sp>
+      <p:sp>
+        <p:nvSpPr>
+          <p:cNvPr id="7" name="Rectangle 6">
+            <a:extLst>
+              <a:ext uri="{FF2B5EF4-FFF2-40B4-BE49-F238E27FC236}">
+                <a16:creationId xmlns:a16="http://schemas.microsoft.com/office/drawing/2014/main" id="{669EB4B6-F23A-75E2-3B2B-CDD29A35B45E}"/>
+              </a:ext>
+            </a:extLst>
+          </p:cNvPr>
+          <p:cNvSpPr/>
+          <p:nvPr/>
+        </p:nvSpPr>
+        <p:spPr>
+          <a:xfrm>
+            <a:off x="242978" y="2813298"/>
+            <a:ext cx="2574000" cy="1137600"/>
+          </a:xfrm>
+          <a:prstGeom prst="rect">
+            <a:avLst/>
+          </a:prstGeom>
+        </p:spPr>
+        <p:style>
+          <a:lnRef idx="2">
+            <a:schemeClr val="accent3">
+              <a:shade val="15000"/>
+            </a:schemeClr>
+          </a:lnRef>
+          <a:fillRef idx="1">
+            <a:schemeClr val="accent3"/>
+          </a:fillRef>
+          <a:effectRef idx="0">
+            <a:schemeClr val="accent3"/>
+          </a:effectRef>
+          <a:fontRef idx="minor">
+            <a:schemeClr val="lt1"/>
+          </a:fontRef>
+        </p:style>
+        <p:txBody>
+          <a:bodyPr rtlCol="0" anchor="ctr"/>
+          <a:lstStyle/>
+          <a:p>
+            <a:pPr algn="ctr"/>
+            <a:r>
+              <a:rPr lang="en-US" sz="1400" dirty="0"/>
+              <a:t>SbSe = HWOT = 157.9 nm</a:t>
+            </a:r>
+            <a:endParaRPr lang="en-GB" sz="1400" dirty="0"/>
+          </a:p>
+        </p:txBody>
+      </p:sp>
+      <p:sp>
+        <p:nvSpPr>
+          <p:cNvPr id="13" name="Rectangle 12">
+            <a:extLst>
+              <a:ext uri="{FF2B5EF4-FFF2-40B4-BE49-F238E27FC236}">
+                <a16:creationId xmlns:a16="http://schemas.microsoft.com/office/drawing/2014/main" id="{4D0FF5D4-2C50-9445-B36F-EAC450A27209}"/>
+              </a:ext>
+            </a:extLst>
+          </p:cNvPr>
+          <p:cNvSpPr/>
+          <p:nvPr/>
+        </p:nvSpPr>
+        <p:spPr>
+          <a:xfrm>
+            <a:off x="5948017" y="3939423"/>
+            <a:ext cx="2573546" cy="2880000"/>
+          </a:xfrm>
+          <a:prstGeom prst="rect">
+            <a:avLst/>
+          </a:prstGeom>
+        </p:spPr>
+        <p:style>
+          <a:lnRef idx="2">
+            <a:schemeClr val="accent1">
+              <a:shade val="15000"/>
+            </a:schemeClr>
+          </a:lnRef>
+          <a:fillRef idx="1">
+            <a:schemeClr val="accent1"/>
+          </a:fillRef>
+          <a:effectRef idx="0">
+            <a:schemeClr val="accent1"/>
+          </a:effectRef>
+          <a:fontRef idx="minor">
+            <a:schemeClr val="lt1"/>
+          </a:fontRef>
+        </p:style>
+        <p:txBody>
+          <a:bodyPr rtlCol="0" anchor="ctr"/>
+          <a:lstStyle/>
+          <a:p>
+            <a:pPr algn="ctr"/>
+            <a:r>
+              <a:rPr lang="en-US" dirty="0"/>
+              <a:t>SiO2 = 3 mm</a:t>
+            </a:r>
+            <a:endParaRPr lang="en-GB" dirty="0"/>
+          </a:p>
+        </p:txBody>
+      </p:sp>
+      <p:sp>
+        <p:nvSpPr>
+          <p:cNvPr id="14" name="Rectangle 13">
+            <a:extLst>
+              <a:ext uri="{FF2B5EF4-FFF2-40B4-BE49-F238E27FC236}">
+                <a16:creationId xmlns:a16="http://schemas.microsoft.com/office/drawing/2014/main" id="{0366D472-BD2F-A3AA-F552-8E3AF7BA9D52}"/>
+              </a:ext>
+            </a:extLst>
+          </p:cNvPr>
+          <p:cNvSpPr/>
+          <p:nvPr/>
+        </p:nvSpPr>
+        <p:spPr>
+          <a:xfrm>
+            <a:off x="5948016" y="3781023"/>
+            <a:ext cx="2573547" cy="158400"/>
+          </a:xfrm>
+          <a:prstGeom prst="rect">
+            <a:avLst/>
+          </a:prstGeom>
+        </p:spPr>
+        <p:style>
+          <a:lnRef idx="2">
+            <a:schemeClr val="accent3">
+              <a:shade val="15000"/>
+            </a:schemeClr>
+          </a:lnRef>
+          <a:fillRef idx="1">
+            <a:schemeClr val="accent3"/>
+          </a:fillRef>
+          <a:effectRef idx="0">
+            <a:schemeClr val="accent3"/>
+          </a:effectRef>
+          <a:fontRef idx="minor">
+            <a:schemeClr val="lt1"/>
+          </a:fontRef>
+        </p:style>
+        <p:txBody>
+          <a:bodyPr rtlCol="0" anchor="ctr"/>
+          <a:lstStyle/>
+          <a:p>
+            <a:pPr algn="ctr"/>
+            <a:r>
+              <a:rPr lang="en-US" sz="1400" dirty="0"/>
+              <a:t>SbSe = QWOT/2 = 24.75 nm</a:t>
+            </a:r>
+            <a:endParaRPr lang="en-GB" sz="1400" dirty="0"/>
+          </a:p>
+        </p:txBody>
+      </p:sp>
+      <p:sp>
+        <p:nvSpPr>
+          <p:cNvPr id="15" name="Rectangle 14">
+            <a:extLst>
+              <a:ext uri="{FF2B5EF4-FFF2-40B4-BE49-F238E27FC236}">
+                <a16:creationId xmlns:a16="http://schemas.microsoft.com/office/drawing/2014/main" id="{FB188F5B-2ADD-4A08-983C-E38EB8386D17}"/>
+              </a:ext>
+            </a:extLst>
+          </p:cNvPr>
+          <p:cNvSpPr/>
+          <p:nvPr/>
+        </p:nvSpPr>
+        <p:spPr>
+          <a:xfrm>
+            <a:off x="5948017" y="2801823"/>
+            <a:ext cx="2573546" cy="979200"/>
+          </a:xfrm>
+          <a:prstGeom prst="rect">
+            <a:avLst/>
+          </a:prstGeom>
+        </p:spPr>
+        <p:style>
+          <a:lnRef idx="1">
+            <a:schemeClr val="dk1"/>
+          </a:lnRef>
+          <a:fillRef idx="2">
+            <a:schemeClr val="dk1"/>
+          </a:fillRef>
+          <a:effectRef idx="1">
+            <a:schemeClr val="dk1"/>
+          </a:effectRef>
+          <a:fontRef idx="minor">
+            <a:schemeClr val="dk1"/>
+          </a:fontRef>
+        </p:style>
+        <p:txBody>
+          <a:bodyPr rtlCol="0" anchor="ctr"/>
+          <a:lstStyle/>
+          <a:p>
+            <a:pPr algn="ctr"/>
+            <a:r>
+              <a:rPr lang="en-US" sz="1400" dirty="0"/>
+              <a:t>MgF2 = QWOT = 135.8 nm</a:t>
+            </a:r>
+            <a:endParaRPr lang="en-GB" sz="1400" dirty="0"/>
+          </a:p>
+        </p:txBody>
+      </p:sp>
+      <p:sp>
+        <p:nvSpPr>
+          <p:cNvPr id="16" name="Rectangle 15">
+            <a:extLst>
+              <a:ext uri="{FF2B5EF4-FFF2-40B4-BE49-F238E27FC236}">
+                <a16:creationId xmlns:a16="http://schemas.microsoft.com/office/drawing/2014/main" id="{B018411A-1B30-8459-ABA9-88821A9E8760}"/>
+              </a:ext>
+            </a:extLst>
+          </p:cNvPr>
+          <p:cNvSpPr/>
+          <p:nvPr/>
+        </p:nvSpPr>
+        <p:spPr>
+          <a:xfrm>
+            <a:off x="5948015" y="2643423"/>
+            <a:ext cx="2573547" cy="158400"/>
+          </a:xfrm>
+          <a:prstGeom prst="rect">
+            <a:avLst/>
+          </a:prstGeom>
+        </p:spPr>
+        <p:style>
+          <a:lnRef idx="2">
+            <a:schemeClr val="accent3">
+              <a:shade val="15000"/>
+            </a:schemeClr>
+          </a:lnRef>
+          <a:fillRef idx="1">
+            <a:schemeClr val="accent3"/>
+          </a:fillRef>
+          <a:effectRef idx="0">
+            <a:schemeClr val="accent3"/>
+          </a:effectRef>
+          <a:fontRef idx="minor">
+            <a:schemeClr val="lt1"/>
+          </a:fontRef>
+        </p:style>
+        <p:txBody>
+          <a:bodyPr rtlCol="0" anchor="ctr"/>
+          <a:lstStyle/>
+          <a:p>
+            <a:pPr algn="ctr"/>
+            <a:r>
+              <a:rPr lang="en-US" sz="1400" dirty="0"/>
+              <a:t>SbSe = QWOT/2 = 24.75 nm</a:t>
+            </a:r>
+            <a:endParaRPr lang="en-GB" sz="1400" dirty="0"/>
+          </a:p>
+        </p:txBody>
+      </p:sp>
+      <p:sp>
+        <p:nvSpPr>
+          <p:cNvPr id="17" name="Right Brace 16">
+            <a:extLst>
+              <a:ext uri="{FF2B5EF4-FFF2-40B4-BE49-F238E27FC236}">
+                <a16:creationId xmlns:a16="http://schemas.microsoft.com/office/drawing/2014/main" id="{8F45445A-A521-8FB7-468D-02D363F82511}"/>
+              </a:ext>
+            </a:extLst>
+          </p:cNvPr>
+          <p:cNvSpPr/>
+          <p:nvPr/>
+        </p:nvSpPr>
+        <p:spPr>
+          <a:xfrm>
+            <a:off x="8521562" y="2643423"/>
+            <a:ext cx="180582" cy="1296000"/>
+          </a:xfrm>
+          <a:prstGeom prst="rightBrace">
+            <a:avLst/>
+          </a:prstGeom>
+        </p:spPr>
+        <p:style>
+          <a:lnRef idx="2">
+            <a:schemeClr val="dk1"/>
+          </a:lnRef>
+          <a:fillRef idx="0">
+            <a:schemeClr val="dk1"/>
+          </a:fillRef>
+          <a:effectRef idx="1">
+            <a:schemeClr val="dk1"/>
+          </a:effectRef>
+          <a:fontRef idx="minor">
+            <a:schemeClr val="tx1"/>
+          </a:fontRef>
+        </p:style>
+        <p:txBody>
+          <a:bodyPr rtlCol="0" anchor="ctr"/>
+          <a:lstStyle/>
+          <a:p>
+            <a:pPr algn="ctr"/>
+            <a:endParaRPr lang="en-GB"/>
+          </a:p>
+        </p:txBody>
+      </p:sp>
+      <p:sp>
+        <p:nvSpPr>
+          <p:cNvPr id="18" name="TextBox 17">
+            <a:extLst>
+              <a:ext uri="{FF2B5EF4-FFF2-40B4-BE49-F238E27FC236}">
+                <a16:creationId xmlns:a16="http://schemas.microsoft.com/office/drawing/2014/main" id="{9280710D-6676-AF03-B91F-969A57448359}"/>
+              </a:ext>
+            </a:extLst>
+          </p:cNvPr>
+          <p:cNvSpPr txBox="1"/>
+          <p:nvPr/>
+        </p:nvSpPr>
+        <p:spPr>
+          <a:xfrm rot="5400000">
+            <a:off x="8233682" y="3106757"/>
+            <a:ext cx="1178464" cy="369332"/>
+          </a:xfrm>
+          <a:prstGeom prst="rect">
+            <a:avLst/>
+          </a:prstGeom>
+          <a:noFill/>
+        </p:spPr>
+        <p:txBody>
+          <a:bodyPr wrap="none" rtlCol="0">
+            <a:spAutoFit/>
+          </a:bodyPr>
+          <a:lstStyle/>
+          <a:p>
+            <a:r>
+              <a:rPr lang="en-US" dirty="0"/>
+              <a:t>1 unit-cell</a:t>
+            </a:r>
+            <a:endParaRPr lang="en-GB" dirty="0"/>
+          </a:p>
+        </p:txBody>
+      </p:sp>
+      <p:sp>
+        <p:nvSpPr>
+          <p:cNvPr id="19" name="TextBox 18">
+            <a:extLst>
+              <a:ext uri="{FF2B5EF4-FFF2-40B4-BE49-F238E27FC236}">
+                <a16:creationId xmlns:a16="http://schemas.microsoft.com/office/drawing/2014/main" id="{BA8E587C-6BC9-F98C-E882-7C9A8705D3DD}"/>
+              </a:ext>
+            </a:extLst>
+          </p:cNvPr>
+          <p:cNvSpPr txBox="1"/>
+          <p:nvPr/>
+        </p:nvSpPr>
+        <p:spPr>
+          <a:xfrm>
+            <a:off x="854601" y="2050255"/>
+            <a:ext cx="1350754" cy="369332"/>
+          </a:xfrm>
+          <a:prstGeom prst="rect">
+            <a:avLst/>
+          </a:prstGeom>
+          <a:noFill/>
+        </p:spPr>
+        <p:txBody>
+          <a:bodyPr wrap="none" rtlCol="0">
+            <a:spAutoFit/>
+          </a:bodyPr>
+          <a:lstStyle/>
+          <a:p>
+            <a:r>
+              <a:rPr lang="en-US" dirty="0"/>
+              <a:t>Single-layer</a:t>
+            </a:r>
+          </a:p>
+        </p:txBody>
+      </p:sp>
+      <p:sp>
+        <p:nvSpPr>
+          <p:cNvPr id="20" name="TextBox 19">
+            <a:extLst>
+              <a:ext uri="{FF2B5EF4-FFF2-40B4-BE49-F238E27FC236}">
+                <a16:creationId xmlns:a16="http://schemas.microsoft.com/office/drawing/2014/main" id="{ABC1627F-DD60-AB37-C2C8-5D6314FA462C}"/>
+              </a:ext>
+            </a:extLst>
+          </p:cNvPr>
+          <p:cNvSpPr txBox="1"/>
+          <p:nvPr/>
+        </p:nvSpPr>
+        <p:spPr>
+          <a:xfrm>
+            <a:off x="6334349" y="2045925"/>
+            <a:ext cx="1800878" cy="369332"/>
+          </a:xfrm>
+          <a:prstGeom prst="rect">
+            <a:avLst/>
+          </a:prstGeom>
+          <a:noFill/>
+        </p:spPr>
+        <p:txBody>
+          <a:bodyPr wrap="none" rtlCol="0">
+            <a:spAutoFit/>
+          </a:bodyPr>
+          <a:lstStyle/>
+          <a:p>
+            <a:r>
+              <a:rPr lang="en-US" dirty="0"/>
+              <a:t>Edge-filter (N=1)</a:t>
+            </a:r>
+            <a:endParaRPr lang="en-GB" dirty="0"/>
+          </a:p>
+        </p:txBody>
+      </p:sp>
+      <p:sp>
+        <p:nvSpPr>
+          <p:cNvPr id="21" name="Rectangle 20">
+            <a:extLst>
+              <a:ext uri="{FF2B5EF4-FFF2-40B4-BE49-F238E27FC236}">
+                <a16:creationId xmlns:a16="http://schemas.microsoft.com/office/drawing/2014/main" id="{2FD99E1F-05A9-B451-9D8D-D61F2E555BDD}"/>
+              </a:ext>
+            </a:extLst>
+          </p:cNvPr>
+          <p:cNvSpPr/>
+          <p:nvPr/>
+        </p:nvSpPr>
+        <p:spPr>
+          <a:xfrm>
+            <a:off x="9007583" y="3950898"/>
+            <a:ext cx="2573546" cy="2880000"/>
+          </a:xfrm>
+          <a:prstGeom prst="rect">
+            <a:avLst/>
+          </a:prstGeom>
+        </p:spPr>
+        <p:style>
+          <a:lnRef idx="2">
+            <a:schemeClr val="accent1">
+              <a:shade val="15000"/>
+            </a:schemeClr>
+          </a:lnRef>
+          <a:fillRef idx="1">
+            <a:schemeClr val="accent1"/>
+          </a:fillRef>
+          <a:effectRef idx="0">
+            <a:schemeClr val="accent1"/>
+          </a:effectRef>
+          <a:fontRef idx="minor">
+            <a:schemeClr val="lt1"/>
+          </a:fontRef>
+        </p:style>
+        <p:txBody>
+          <a:bodyPr rtlCol="0" anchor="ctr"/>
+          <a:lstStyle/>
+          <a:p>
+            <a:pPr algn="ctr"/>
+            <a:r>
+              <a:rPr lang="en-US" dirty="0"/>
+              <a:t>SiO2 = 3 mm</a:t>
+            </a:r>
+            <a:endParaRPr lang="en-GB" dirty="0"/>
+          </a:p>
+        </p:txBody>
+      </p:sp>
+      <p:sp>
+        <p:nvSpPr>
+          <p:cNvPr id="22" name="Rectangle 21">
+            <a:extLst>
+              <a:ext uri="{FF2B5EF4-FFF2-40B4-BE49-F238E27FC236}">
+                <a16:creationId xmlns:a16="http://schemas.microsoft.com/office/drawing/2014/main" id="{D8809364-75AA-C3F1-20D1-8CFE13505018}"/>
+              </a:ext>
+            </a:extLst>
+          </p:cNvPr>
+          <p:cNvSpPr/>
+          <p:nvPr/>
+        </p:nvSpPr>
+        <p:spPr>
+          <a:xfrm>
+            <a:off x="9007582" y="3792498"/>
+            <a:ext cx="2573547" cy="158400"/>
+          </a:xfrm>
+          <a:prstGeom prst="rect">
+            <a:avLst/>
+          </a:prstGeom>
+        </p:spPr>
+        <p:style>
+          <a:lnRef idx="2">
+            <a:schemeClr val="accent3">
+              <a:shade val="15000"/>
+            </a:schemeClr>
+          </a:lnRef>
+          <a:fillRef idx="1">
+            <a:schemeClr val="accent3"/>
+          </a:fillRef>
+          <a:effectRef idx="0">
+            <a:schemeClr val="accent3"/>
+          </a:effectRef>
+          <a:fontRef idx="minor">
+            <a:schemeClr val="lt1"/>
+          </a:fontRef>
+        </p:style>
+        <p:txBody>
+          <a:bodyPr rtlCol="0" anchor="ctr"/>
+          <a:lstStyle/>
+          <a:p>
+            <a:pPr algn="ctr"/>
+            <a:r>
+              <a:rPr lang="en-US" sz="1400" dirty="0"/>
+              <a:t>SbSe = QWOT/2 = 24.75 nm</a:t>
+            </a:r>
+            <a:endParaRPr lang="en-GB" sz="1400" dirty="0"/>
+          </a:p>
+        </p:txBody>
+      </p:sp>
+      <p:sp>
+        <p:nvSpPr>
+          <p:cNvPr id="23" name="Rectangle 22">
+            <a:extLst>
+              <a:ext uri="{FF2B5EF4-FFF2-40B4-BE49-F238E27FC236}">
+                <a16:creationId xmlns:a16="http://schemas.microsoft.com/office/drawing/2014/main" id="{4C9CB607-FEA2-650E-A719-4F28010092A3}"/>
+              </a:ext>
+            </a:extLst>
+          </p:cNvPr>
+          <p:cNvSpPr/>
+          <p:nvPr/>
+        </p:nvSpPr>
+        <p:spPr>
+          <a:xfrm>
+            <a:off x="9007583" y="2813298"/>
+            <a:ext cx="2573546" cy="979200"/>
+          </a:xfrm>
+          <a:prstGeom prst="rect">
+            <a:avLst/>
+          </a:prstGeom>
+        </p:spPr>
+        <p:style>
+          <a:lnRef idx="1">
+            <a:schemeClr val="dk1"/>
+          </a:lnRef>
+          <a:fillRef idx="2">
+            <a:schemeClr val="dk1"/>
+          </a:fillRef>
+          <a:effectRef idx="1">
+            <a:schemeClr val="dk1"/>
+          </a:effectRef>
+          <a:fontRef idx="minor">
+            <a:schemeClr val="dk1"/>
+          </a:fontRef>
+        </p:style>
+        <p:txBody>
+          <a:bodyPr rtlCol="0" anchor="ctr"/>
+          <a:lstStyle/>
+          <a:p>
+            <a:pPr algn="ctr"/>
+            <a:r>
+              <a:rPr lang="en-US" sz="1400" dirty="0"/>
+              <a:t>MgF = QWOT = 135.8 nm</a:t>
+            </a:r>
+            <a:endParaRPr lang="en-GB" sz="1400" dirty="0"/>
+          </a:p>
+        </p:txBody>
+      </p:sp>
+      <p:sp>
+        <p:nvSpPr>
+          <p:cNvPr id="24" name="Rectangle 23">
+            <a:extLst>
+              <a:ext uri="{FF2B5EF4-FFF2-40B4-BE49-F238E27FC236}">
+                <a16:creationId xmlns:a16="http://schemas.microsoft.com/office/drawing/2014/main" id="{080152D1-267E-B4B4-232D-75BAF6749A75}"/>
+              </a:ext>
+            </a:extLst>
+          </p:cNvPr>
+          <p:cNvSpPr/>
+          <p:nvPr/>
+        </p:nvSpPr>
+        <p:spPr>
+          <a:xfrm>
+            <a:off x="9007581" y="2654898"/>
+            <a:ext cx="2573547" cy="158400"/>
+          </a:xfrm>
+          <a:prstGeom prst="rect">
+            <a:avLst/>
+          </a:prstGeom>
+        </p:spPr>
+        <p:style>
+          <a:lnRef idx="2">
+            <a:schemeClr val="accent3">
+              <a:shade val="15000"/>
+            </a:schemeClr>
+          </a:lnRef>
+          <a:fillRef idx="1">
+            <a:schemeClr val="accent3"/>
+          </a:fillRef>
+          <a:effectRef idx="0">
+            <a:schemeClr val="accent3"/>
+          </a:effectRef>
+          <a:fontRef idx="minor">
+            <a:schemeClr val="lt1"/>
+          </a:fontRef>
+        </p:style>
+        <p:txBody>
+          <a:bodyPr rtlCol="0" anchor="ctr"/>
+          <a:lstStyle/>
+          <a:p>
+            <a:pPr algn="ctr"/>
+            <a:r>
+              <a:rPr lang="en-US" sz="1400" dirty="0"/>
+              <a:t>SbSe = QWOT/2 = 24.75 nm</a:t>
+            </a:r>
+            <a:endParaRPr lang="en-GB" sz="1400" dirty="0"/>
+          </a:p>
+        </p:txBody>
+      </p:sp>
+      <p:sp>
+        <p:nvSpPr>
+          <p:cNvPr id="25" name="Right Brace 24">
+            <a:extLst>
+              <a:ext uri="{FF2B5EF4-FFF2-40B4-BE49-F238E27FC236}">
+                <a16:creationId xmlns:a16="http://schemas.microsoft.com/office/drawing/2014/main" id="{E976946A-6C00-9830-38EA-3ADFFF791E98}"/>
+              </a:ext>
+            </a:extLst>
+          </p:cNvPr>
+          <p:cNvSpPr/>
+          <p:nvPr/>
+        </p:nvSpPr>
+        <p:spPr>
+          <a:xfrm>
+            <a:off x="11581128" y="1358898"/>
+            <a:ext cx="241540" cy="2592000"/>
+          </a:xfrm>
+          <a:prstGeom prst="rightBrace">
+            <a:avLst/>
+          </a:prstGeom>
+        </p:spPr>
+        <p:style>
+          <a:lnRef idx="2">
+            <a:schemeClr val="dk1"/>
+          </a:lnRef>
+          <a:fillRef idx="0">
+            <a:schemeClr val="dk1"/>
+          </a:fillRef>
+          <a:effectRef idx="1">
+            <a:schemeClr val="dk1"/>
+          </a:effectRef>
+          <a:fontRef idx="minor">
+            <a:schemeClr val="tx1"/>
+          </a:fontRef>
+        </p:style>
+        <p:txBody>
+          <a:bodyPr rtlCol="0" anchor="ctr"/>
+          <a:lstStyle/>
+          <a:p>
+            <a:pPr algn="ctr"/>
+            <a:endParaRPr lang="en-GB"/>
+          </a:p>
+        </p:txBody>
+      </p:sp>
+      <p:sp>
+        <p:nvSpPr>
+          <p:cNvPr id="26" name="TextBox 25">
+            <a:extLst>
+              <a:ext uri="{FF2B5EF4-FFF2-40B4-BE49-F238E27FC236}">
+                <a16:creationId xmlns:a16="http://schemas.microsoft.com/office/drawing/2014/main" id="{922116EC-14CA-4452-990D-582CCDD2ABE4}"/>
+              </a:ext>
+            </a:extLst>
+          </p:cNvPr>
+          <p:cNvSpPr txBox="1"/>
+          <p:nvPr/>
+        </p:nvSpPr>
+        <p:spPr>
+          <a:xfrm rot="5400000">
+            <a:off x="11313436" y="2482955"/>
+            <a:ext cx="1290674" cy="369332"/>
+          </a:xfrm>
+          <a:prstGeom prst="rect">
+            <a:avLst/>
+          </a:prstGeom>
+          <a:noFill/>
+        </p:spPr>
+        <p:txBody>
+          <a:bodyPr wrap="none" rtlCol="0">
+            <a:spAutoFit/>
+          </a:bodyPr>
+          <a:lstStyle/>
+          <a:p>
+            <a:r>
+              <a:rPr lang="en-US" dirty="0"/>
+              <a:t>2 unit-cells</a:t>
+            </a:r>
+            <a:endParaRPr lang="en-GB" dirty="0"/>
+          </a:p>
+        </p:txBody>
+      </p:sp>
+      <p:sp>
+        <p:nvSpPr>
+          <p:cNvPr id="27" name="TextBox 26">
+            <a:extLst>
+              <a:ext uri="{FF2B5EF4-FFF2-40B4-BE49-F238E27FC236}">
+                <a16:creationId xmlns:a16="http://schemas.microsoft.com/office/drawing/2014/main" id="{7823B244-D01A-EDDE-FBC4-CB624BF66168}"/>
+              </a:ext>
+            </a:extLst>
+          </p:cNvPr>
+          <p:cNvSpPr txBox="1"/>
+          <p:nvPr/>
+        </p:nvSpPr>
+        <p:spPr>
+          <a:xfrm>
+            <a:off x="9393915" y="877093"/>
+            <a:ext cx="1800878" cy="369332"/>
+          </a:xfrm>
+          <a:prstGeom prst="rect">
+            <a:avLst/>
+          </a:prstGeom>
+          <a:noFill/>
+        </p:spPr>
+        <p:txBody>
+          <a:bodyPr wrap="none" rtlCol="0">
+            <a:spAutoFit/>
+          </a:bodyPr>
+          <a:lstStyle/>
+          <a:p>
+            <a:r>
+              <a:rPr lang="en-US" dirty="0"/>
+              <a:t>Edge-filter (N=2)</a:t>
+            </a:r>
+            <a:endParaRPr lang="en-GB" dirty="0"/>
+          </a:p>
+        </p:txBody>
+      </p:sp>
+      <p:sp>
+        <p:nvSpPr>
+          <p:cNvPr id="28" name="Rectangle 27">
+            <a:extLst>
+              <a:ext uri="{FF2B5EF4-FFF2-40B4-BE49-F238E27FC236}">
+                <a16:creationId xmlns:a16="http://schemas.microsoft.com/office/drawing/2014/main" id="{18E85036-D485-28C9-4022-69648910FB68}"/>
+              </a:ext>
+            </a:extLst>
+          </p:cNvPr>
+          <p:cNvSpPr/>
+          <p:nvPr/>
+        </p:nvSpPr>
+        <p:spPr>
+          <a:xfrm>
+            <a:off x="9007582" y="2496498"/>
+            <a:ext cx="2573547" cy="158400"/>
+          </a:xfrm>
+          <a:prstGeom prst="rect">
+            <a:avLst/>
+          </a:prstGeom>
+        </p:spPr>
+        <p:style>
+          <a:lnRef idx="2">
+            <a:schemeClr val="accent3">
+              <a:shade val="15000"/>
+            </a:schemeClr>
+          </a:lnRef>
+          <a:fillRef idx="1">
+            <a:schemeClr val="accent3"/>
+          </a:fillRef>
+          <a:effectRef idx="0">
+            <a:schemeClr val="accent3"/>
+          </a:effectRef>
+          <a:fontRef idx="minor">
+            <a:schemeClr val="lt1"/>
+          </a:fontRef>
+        </p:style>
+        <p:txBody>
+          <a:bodyPr rtlCol="0" anchor="ctr"/>
+          <a:lstStyle/>
+          <a:p>
+            <a:pPr algn="ctr"/>
+            <a:r>
+              <a:rPr lang="en-US" sz="1400" dirty="0"/>
+              <a:t>SbSe = QWOT/2 = 24.75 nm</a:t>
+            </a:r>
+            <a:endParaRPr lang="en-GB" sz="1400" dirty="0"/>
+          </a:p>
+        </p:txBody>
+      </p:sp>
+      <p:sp>
+        <p:nvSpPr>
+          <p:cNvPr id="29" name="Rectangle 28">
+            <a:extLst>
+              <a:ext uri="{FF2B5EF4-FFF2-40B4-BE49-F238E27FC236}">
+                <a16:creationId xmlns:a16="http://schemas.microsoft.com/office/drawing/2014/main" id="{73C4423F-F667-4525-1572-B01F68B86295}"/>
+              </a:ext>
+            </a:extLst>
+          </p:cNvPr>
+          <p:cNvSpPr/>
+          <p:nvPr/>
+        </p:nvSpPr>
+        <p:spPr>
+          <a:xfrm>
+            <a:off x="9007583" y="1517298"/>
+            <a:ext cx="2573546" cy="979200"/>
+          </a:xfrm>
+          <a:prstGeom prst="rect">
+            <a:avLst/>
+          </a:prstGeom>
+        </p:spPr>
+        <p:style>
+          <a:lnRef idx="1">
+            <a:schemeClr val="dk1"/>
+          </a:lnRef>
+          <a:fillRef idx="2">
+            <a:schemeClr val="dk1"/>
+          </a:fillRef>
+          <a:effectRef idx="1">
+            <a:schemeClr val="dk1"/>
+          </a:effectRef>
+          <a:fontRef idx="minor">
+            <a:schemeClr val="dk1"/>
+          </a:fontRef>
+        </p:style>
+        <p:txBody>
+          <a:bodyPr rtlCol="0" anchor="ctr"/>
+          <a:lstStyle/>
+          <a:p>
+            <a:pPr algn="ctr"/>
+            <a:r>
+              <a:rPr lang="en-US" sz="1400" dirty="0"/>
+              <a:t>MgF = QWOT = 135.8 nm</a:t>
+            </a:r>
+            <a:endParaRPr lang="en-GB" sz="1400" dirty="0"/>
+          </a:p>
+        </p:txBody>
+      </p:sp>
+      <p:sp>
+        <p:nvSpPr>
+          <p:cNvPr id="30" name="Rectangle 29">
+            <a:extLst>
+              <a:ext uri="{FF2B5EF4-FFF2-40B4-BE49-F238E27FC236}">
+                <a16:creationId xmlns:a16="http://schemas.microsoft.com/office/drawing/2014/main" id="{F6BB258B-651A-081F-F261-D62B6391E46B}"/>
+              </a:ext>
+            </a:extLst>
+          </p:cNvPr>
+          <p:cNvSpPr/>
+          <p:nvPr/>
+        </p:nvSpPr>
+        <p:spPr>
+          <a:xfrm>
+            <a:off x="9007581" y="1358898"/>
+            <a:ext cx="2573547" cy="158400"/>
+          </a:xfrm>
+          <a:prstGeom prst="rect">
+            <a:avLst/>
+          </a:prstGeom>
+        </p:spPr>
+        <p:style>
+          <a:lnRef idx="2">
+            <a:schemeClr val="accent3">
+              <a:shade val="15000"/>
+            </a:schemeClr>
+          </a:lnRef>
+          <a:fillRef idx="1">
+            <a:schemeClr val="accent3"/>
+          </a:fillRef>
+          <a:effectRef idx="0">
+            <a:schemeClr val="accent3"/>
+          </a:effectRef>
+          <a:fontRef idx="minor">
+            <a:schemeClr val="lt1"/>
+          </a:fontRef>
+        </p:style>
+        <p:txBody>
+          <a:bodyPr rtlCol="0" anchor="ctr"/>
+          <a:lstStyle/>
+          <a:p>
+            <a:pPr algn="ctr"/>
+            <a:r>
+              <a:rPr lang="en-US" sz="1400" dirty="0"/>
+              <a:t>SbSe = QWOT/2 = 24.75 nm</a:t>
+            </a:r>
+            <a:endParaRPr lang="en-GB" sz="1400" dirty="0"/>
+          </a:p>
+        </p:txBody>
+      </p:sp>
+      <p:sp>
+        <p:nvSpPr>
+          <p:cNvPr id="3" name="Rectangle 2">
+            <a:extLst>
+              <a:ext uri="{FF2B5EF4-FFF2-40B4-BE49-F238E27FC236}">
+                <a16:creationId xmlns:a16="http://schemas.microsoft.com/office/drawing/2014/main" id="{0DEB9718-38B6-7A11-3604-B148A916B45E}"/>
+              </a:ext>
+            </a:extLst>
+          </p:cNvPr>
+          <p:cNvSpPr/>
+          <p:nvPr/>
+        </p:nvSpPr>
+        <p:spPr>
+          <a:xfrm>
+            <a:off x="3009502" y="3950898"/>
+            <a:ext cx="2574000" cy="2880000"/>
+          </a:xfrm>
+          <a:prstGeom prst="rect">
+            <a:avLst/>
+          </a:prstGeom>
+        </p:spPr>
+        <p:style>
+          <a:lnRef idx="2">
+            <a:schemeClr val="accent1">
+              <a:shade val="15000"/>
+            </a:schemeClr>
+          </a:lnRef>
+          <a:fillRef idx="1">
+            <a:schemeClr val="accent1"/>
+          </a:fillRef>
+          <a:effectRef idx="0">
+            <a:schemeClr val="accent1"/>
+          </a:effectRef>
+          <a:fontRef idx="minor">
+            <a:schemeClr val="lt1"/>
+          </a:fontRef>
+        </p:style>
+        <p:txBody>
+          <a:bodyPr rtlCol="0" anchor="ctr"/>
+          <a:lstStyle/>
+          <a:p>
+            <a:pPr algn="ctr"/>
+            <a:r>
+              <a:rPr lang="en-US" dirty="0"/>
+              <a:t>SiO2 = 3 mm</a:t>
+            </a:r>
+            <a:endParaRPr lang="en-GB" dirty="0"/>
+          </a:p>
+        </p:txBody>
+      </p:sp>
+      <p:sp>
+        <p:nvSpPr>
+          <p:cNvPr id="4" name="Rectangle 3">
+            <a:extLst>
+              <a:ext uri="{FF2B5EF4-FFF2-40B4-BE49-F238E27FC236}">
+                <a16:creationId xmlns:a16="http://schemas.microsoft.com/office/drawing/2014/main" id="{C80BAF52-D55B-8613-B1C4-F720818C2280}"/>
+              </a:ext>
+            </a:extLst>
+          </p:cNvPr>
+          <p:cNvSpPr/>
+          <p:nvPr/>
+        </p:nvSpPr>
+        <p:spPr>
+          <a:xfrm>
+            <a:off x="3009502" y="3385521"/>
+            <a:ext cx="2574000" cy="568800"/>
+          </a:xfrm>
+          <a:prstGeom prst="rect">
+            <a:avLst/>
+          </a:prstGeom>
+        </p:spPr>
+        <p:style>
+          <a:lnRef idx="2">
+            <a:schemeClr val="accent3">
+              <a:shade val="15000"/>
+            </a:schemeClr>
+          </a:lnRef>
+          <a:fillRef idx="1">
+            <a:schemeClr val="accent3"/>
+          </a:fillRef>
+          <a:effectRef idx="0">
+            <a:schemeClr val="accent3"/>
+          </a:effectRef>
+          <a:fontRef idx="minor">
+            <a:schemeClr val="lt1"/>
+          </a:fontRef>
+        </p:style>
+        <p:txBody>
+          <a:bodyPr rtlCol="0" anchor="ctr"/>
+          <a:lstStyle/>
+          <a:p>
+            <a:pPr algn="ctr"/>
+            <a:r>
+              <a:rPr lang="en-US" sz="1400" dirty="0"/>
+              <a:t>SbSe = QWOT = 78.9 nm</a:t>
+            </a:r>
+            <a:endParaRPr lang="en-GB" sz="1400" dirty="0"/>
+          </a:p>
+        </p:txBody>
+      </p:sp>
+      <p:sp>
+        <p:nvSpPr>
+          <p:cNvPr id="6" name="TextBox 5">
+            <a:extLst>
+              <a:ext uri="{FF2B5EF4-FFF2-40B4-BE49-F238E27FC236}">
+                <a16:creationId xmlns:a16="http://schemas.microsoft.com/office/drawing/2014/main" id="{AC5858B5-AFEE-5D5D-90AD-7FEB15583565}"/>
+              </a:ext>
+            </a:extLst>
+          </p:cNvPr>
+          <p:cNvSpPr txBox="1"/>
+          <p:nvPr/>
+        </p:nvSpPr>
+        <p:spPr>
+          <a:xfrm>
+            <a:off x="3621125" y="2045925"/>
+            <a:ext cx="1139992" cy="369332"/>
+          </a:xfrm>
+          <a:prstGeom prst="rect">
+            <a:avLst/>
+          </a:prstGeom>
+          <a:noFill/>
+        </p:spPr>
+        <p:txBody>
+          <a:bodyPr wrap="none" rtlCol="0">
+            <a:spAutoFit/>
+          </a:bodyPr>
+          <a:lstStyle/>
+          <a:p>
+            <a:r>
+              <a:rPr lang="en-US" dirty="0"/>
+              <a:t>Two-layer</a:t>
+            </a:r>
+            <a:endParaRPr lang="en-GB" dirty="0"/>
+          </a:p>
+        </p:txBody>
+      </p:sp>
+      <p:sp>
+        <p:nvSpPr>
+          <p:cNvPr id="8" name="Rectangle 7">
+            <a:extLst>
+              <a:ext uri="{FF2B5EF4-FFF2-40B4-BE49-F238E27FC236}">
+                <a16:creationId xmlns:a16="http://schemas.microsoft.com/office/drawing/2014/main" id="{161FEB63-25B7-D9A4-EA90-03F7FAB5332D}"/>
+              </a:ext>
+            </a:extLst>
+          </p:cNvPr>
+          <p:cNvSpPr/>
+          <p:nvPr/>
+        </p:nvSpPr>
+        <p:spPr>
+          <a:xfrm>
+            <a:off x="3009956" y="2554098"/>
+            <a:ext cx="2573546" cy="828000"/>
+          </a:xfrm>
+          <a:prstGeom prst="rect">
+            <a:avLst/>
+          </a:prstGeom>
+        </p:spPr>
+        <p:style>
+          <a:lnRef idx="1">
+            <a:schemeClr val="accent4"/>
+          </a:lnRef>
+          <a:fillRef idx="2">
+            <a:schemeClr val="accent4"/>
+          </a:fillRef>
+          <a:effectRef idx="1">
+            <a:schemeClr val="accent4"/>
+          </a:effectRef>
+          <a:fontRef idx="minor">
+            <a:schemeClr val="dk1"/>
+          </a:fontRef>
+        </p:style>
+        <p:txBody>
+          <a:bodyPr rtlCol="0" anchor="ctr"/>
+          <a:lstStyle/>
+          <a:p>
+            <a:pPr algn="ctr"/>
+            <a:r>
+              <a:rPr lang="en-US" sz="1400" dirty="0"/>
+              <a:t>TiO2 = QWOT = 115.2 nm</a:t>
+            </a:r>
+            <a:endParaRPr lang="en-GB" sz="1400" dirty="0"/>
+          </a:p>
+        </p:txBody>
+      </p:sp>
+      <p:sp>
+        <p:nvSpPr>
+          <p:cNvPr id="10" name="Right Brace 9">
+            <a:extLst>
+              <a:ext uri="{FF2B5EF4-FFF2-40B4-BE49-F238E27FC236}">
+                <a16:creationId xmlns:a16="http://schemas.microsoft.com/office/drawing/2014/main" id="{0AA56678-13E9-6A9D-FCEC-B578604D0A4A}"/>
+              </a:ext>
+            </a:extLst>
+          </p:cNvPr>
+          <p:cNvSpPr/>
+          <p:nvPr/>
+        </p:nvSpPr>
+        <p:spPr>
+          <a:xfrm rot="16200000">
+            <a:off x="2787053" y="-720797"/>
+            <a:ext cx="252377" cy="5340526"/>
+          </a:xfrm>
+          <a:prstGeom prst="rightBrace">
+            <a:avLst/>
+          </a:prstGeom>
+          <a:ln>
+            <a:solidFill>
+              <a:srgbClr val="C00000"/>
+            </a:solidFill>
+          </a:ln>
+        </p:spPr>
+        <p:style>
+          <a:lnRef idx="2">
+            <a:schemeClr val="accent2"/>
+          </a:lnRef>
+          <a:fillRef idx="0">
+            <a:schemeClr val="accent2"/>
+          </a:fillRef>
+          <a:effectRef idx="1">
+            <a:schemeClr val="accent2"/>
+          </a:effectRef>
+          <a:fontRef idx="minor">
+            <a:schemeClr val="tx1"/>
+          </a:fontRef>
+        </p:style>
+        <p:txBody>
+          <a:bodyPr rtlCol="0" anchor="ctr"/>
+          <a:lstStyle/>
+          <a:p>
+            <a:pPr algn="ctr"/>
+            <a:endParaRPr lang="en-GB"/>
+          </a:p>
+        </p:txBody>
+      </p:sp>
+      <p:sp>
+        <p:nvSpPr>
+          <p:cNvPr id="11" name="Right Brace 10">
+            <a:extLst>
+              <a:ext uri="{FF2B5EF4-FFF2-40B4-BE49-F238E27FC236}">
+                <a16:creationId xmlns:a16="http://schemas.microsoft.com/office/drawing/2014/main" id="{D4ECC9B5-7D5D-E618-5A9A-EAAFA49C3A23}"/>
+              </a:ext>
+            </a:extLst>
+          </p:cNvPr>
+          <p:cNvSpPr/>
+          <p:nvPr/>
+        </p:nvSpPr>
+        <p:spPr>
+          <a:xfrm rot="16200000">
+            <a:off x="8641712" y="-1950588"/>
+            <a:ext cx="252377" cy="5639771"/>
+          </a:xfrm>
+          <a:prstGeom prst="rightBrace">
+            <a:avLst>
+              <a:gd name="adj1" fmla="val 0"/>
+              <a:gd name="adj2" fmla="val 50000"/>
+            </a:avLst>
+          </a:prstGeom>
+          <a:ln>
+            <a:solidFill>
+              <a:srgbClr val="C00000"/>
+            </a:solidFill>
+          </a:ln>
+        </p:spPr>
+        <p:style>
+          <a:lnRef idx="1">
+            <a:schemeClr val="accent2"/>
+          </a:lnRef>
+          <a:fillRef idx="0">
+            <a:schemeClr val="accent2"/>
+          </a:fillRef>
+          <a:effectRef idx="0">
+            <a:schemeClr val="accent2"/>
+          </a:effectRef>
+          <a:fontRef idx="minor">
+            <a:schemeClr val="tx1"/>
+          </a:fontRef>
+        </p:style>
+        <p:txBody>
+          <a:bodyPr rtlCol="0" anchor="ctr"/>
+          <a:lstStyle/>
+          <a:p>
+            <a:pPr algn="ctr"/>
+            <a:endParaRPr lang="en-GB"/>
+          </a:p>
+        </p:txBody>
+      </p:sp>
+      <p:sp>
+        <p:nvSpPr>
+          <p:cNvPr id="12" name="TextBox 11">
+            <a:extLst>
+              <a:ext uri="{FF2B5EF4-FFF2-40B4-BE49-F238E27FC236}">
+                <a16:creationId xmlns:a16="http://schemas.microsoft.com/office/drawing/2014/main" id="{AEB30283-FF68-47A1-F1DC-D9867349D10E}"/>
+              </a:ext>
+            </a:extLst>
+          </p:cNvPr>
+          <p:cNvSpPr txBox="1"/>
+          <p:nvPr/>
+        </p:nvSpPr>
+        <p:spPr>
+          <a:xfrm>
+            <a:off x="1182511" y="1438098"/>
+            <a:ext cx="3605218" cy="369332"/>
+          </a:xfrm>
+          <a:prstGeom prst="rect">
+            <a:avLst/>
+          </a:prstGeom>
+          <a:noFill/>
+        </p:spPr>
+        <p:txBody>
+          <a:bodyPr wrap="none" rtlCol="0">
+            <a:spAutoFit/>
+          </a:bodyPr>
+          <a:lstStyle/>
+          <a:p>
+            <a:r>
+              <a:rPr lang="en-US" b="1" dirty="0">
+                <a:highlight>
+                  <a:srgbClr val="FF0000"/>
+                </a:highlight>
+              </a:rPr>
+              <a:t>Reference wavelength = 1064 nm</a:t>
+            </a:r>
+            <a:endParaRPr lang="en-GB" b="1" dirty="0">
+              <a:highlight>
+                <a:srgbClr val="FF0000"/>
+              </a:highlight>
+            </a:endParaRPr>
+          </a:p>
+        </p:txBody>
+      </p:sp>
+      <p:sp>
+        <p:nvSpPr>
+          <p:cNvPr id="31" name="TextBox 30">
+            <a:extLst>
+              <a:ext uri="{FF2B5EF4-FFF2-40B4-BE49-F238E27FC236}">
+                <a16:creationId xmlns:a16="http://schemas.microsoft.com/office/drawing/2014/main" id="{3B1E8520-F375-3DB6-DED6-AB7A003E1FC9}"/>
+              </a:ext>
+            </a:extLst>
+          </p:cNvPr>
+          <p:cNvSpPr txBox="1"/>
+          <p:nvPr/>
+        </p:nvSpPr>
+        <p:spPr>
+          <a:xfrm>
+            <a:off x="7037170" y="350264"/>
+            <a:ext cx="3481787" cy="369332"/>
+          </a:xfrm>
+          <a:prstGeom prst="rect">
+            <a:avLst/>
+          </a:prstGeom>
+          <a:noFill/>
+        </p:spPr>
+        <p:txBody>
+          <a:bodyPr wrap="none" rtlCol="0">
+            <a:spAutoFit/>
+          </a:bodyPr>
+          <a:lstStyle/>
+          <a:p>
+            <a:r>
+              <a:rPr lang="en-US" b="1" dirty="0">
+                <a:highlight>
+                  <a:srgbClr val="FF0000"/>
+                </a:highlight>
+              </a:rPr>
+              <a:t>Reference wavelength = 750 nm</a:t>
+            </a:r>
+            <a:endParaRPr lang="en-GB" b="1" dirty="0">
+              <a:highlight>
+                <a:srgbClr val="FF0000"/>
+              </a:highlight>
+            </a:endParaRPr>
+          </a:p>
+        </p:txBody>
+      </p:sp>
+    </p:spTree>
+    <p:extLst>
+      <p:ext uri="{BB962C8B-B14F-4D97-AF65-F5344CB8AC3E}">
+        <p14:creationId xmlns:p14="http://schemas.microsoft.com/office/powerpoint/2010/main" val="2096402023"/>
+      </p:ext>
+    </p:extLst>
+  </p:cSld>
+  <p:clrMapOvr>
+    <a:masterClrMapping/>
+  </p:clrMapOvr>
+</p:sld>
+</file>
+
+<file path=ppt/slides/slide25.xml><?xml version="1.0" encoding="utf-8"?>
+<p:sld xmlns:a="http://schemas.openxmlformats.org/drawingml/2006/main" xmlns:r="http://schemas.openxmlformats.org/officeDocument/2006/relationships" xmlns:p="http://schemas.openxmlformats.org/presentationml/2006/main">
+  <p:cSld>
+    <p:spTree>
+      <p:nvGrpSpPr>
+        <p:cNvPr id="1" name="">
+          <a:extLst>
+            <a:ext uri="{FF2B5EF4-FFF2-40B4-BE49-F238E27FC236}">
+              <a16:creationId xmlns:a16="http://schemas.microsoft.com/office/drawing/2014/main" id="{A4D1B6EA-0A4D-A9F0-C81D-389035288F6C}"/>
+            </a:ext>
+          </a:extLst>
+        </p:cNvPr>
+        <p:cNvGrpSpPr/>
+        <p:nvPr/>
+      </p:nvGrpSpPr>
+      <p:grpSpPr>
+        <a:xfrm>
+          <a:off x="0" y="0"/>
+          <a:ext cx="0" cy="0"/>
+          <a:chOff x="0" y="0"/>
+          <a:chExt cx="0" cy="0"/>
+        </a:xfrm>
+      </p:grpSpPr>
+      <p:sp>
+        <p:nvSpPr>
+          <p:cNvPr id="5" name="Rectangle 4">
+            <a:extLst>
+              <a:ext uri="{FF2B5EF4-FFF2-40B4-BE49-F238E27FC236}">
+                <a16:creationId xmlns:a16="http://schemas.microsoft.com/office/drawing/2014/main" id="{41F4DBD8-2EFF-B8B8-588A-9790C500988A}"/>
+              </a:ext>
+            </a:extLst>
+          </p:cNvPr>
+          <p:cNvSpPr/>
+          <p:nvPr/>
+        </p:nvSpPr>
+        <p:spPr>
+          <a:xfrm>
+            <a:off x="242978" y="3950898"/>
+            <a:ext cx="2574000" cy="2880000"/>
+          </a:xfrm>
+          <a:prstGeom prst="rect">
+            <a:avLst/>
+          </a:prstGeom>
+        </p:spPr>
+        <p:style>
+          <a:lnRef idx="2">
+            <a:schemeClr val="accent1">
+              <a:shade val="15000"/>
+            </a:schemeClr>
+          </a:lnRef>
+          <a:fillRef idx="1">
+            <a:schemeClr val="accent1"/>
+          </a:fillRef>
+          <a:effectRef idx="0">
+            <a:schemeClr val="accent1"/>
+          </a:effectRef>
+          <a:fontRef idx="minor">
+            <a:schemeClr val="lt1"/>
+          </a:fontRef>
+        </p:style>
+        <p:txBody>
+          <a:bodyPr rtlCol="0" anchor="ctr"/>
+          <a:lstStyle/>
+          <a:p>
+            <a:pPr algn="ctr"/>
+            <a:r>
+              <a:rPr lang="en-US" dirty="0"/>
+              <a:t>SiO2 = 3 mm</a:t>
+            </a:r>
+            <a:endParaRPr lang="en-GB" dirty="0"/>
+          </a:p>
+        </p:txBody>
+      </p:sp>
+      <p:sp>
+        <p:nvSpPr>
+          <p:cNvPr id="7" name="Rectangle 6">
+            <a:extLst>
+              <a:ext uri="{FF2B5EF4-FFF2-40B4-BE49-F238E27FC236}">
+                <a16:creationId xmlns:a16="http://schemas.microsoft.com/office/drawing/2014/main" id="{701B9EC9-3C0A-B0D9-52CC-06E5836E0B37}"/>
+              </a:ext>
+            </a:extLst>
+          </p:cNvPr>
+          <p:cNvSpPr/>
+          <p:nvPr/>
+        </p:nvSpPr>
+        <p:spPr>
+          <a:xfrm>
+            <a:off x="242978" y="3478279"/>
+            <a:ext cx="2574000" cy="468000"/>
+          </a:xfrm>
+          <a:prstGeom prst="rect">
+            <a:avLst/>
+          </a:prstGeom>
+        </p:spPr>
+        <p:style>
+          <a:lnRef idx="2">
+            <a:schemeClr val="accent3">
+              <a:shade val="15000"/>
+            </a:schemeClr>
+          </a:lnRef>
+          <a:fillRef idx="1">
+            <a:schemeClr val="accent3"/>
+          </a:fillRef>
+          <a:effectRef idx="0">
+            <a:schemeClr val="accent3"/>
+          </a:effectRef>
+          <a:fontRef idx="minor">
+            <a:schemeClr val="lt1"/>
+          </a:fontRef>
+        </p:style>
+        <p:txBody>
+          <a:bodyPr rtlCol="0" anchor="ctr"/>
+          <a:lstStyle/>
+          <a:p>
+            <a:pPr algn="ctr"/>
+            <a:r>
+              <a:rPr lang="en-US" sz="1400" dirty="0"/>
+              <a:t>SbSe = HWOT = 67.2 nm</a:t>
+            </a:r>
+            <a:endParaRPr lang="en-GB" sz="1400" dirty="0"/>
+          </a:p>
+        </p:txBody>
+      </p:sp>
+      <p:sp>
+        <p:nvSpPr>
+          <p:cNvPr id="13" name="Rectangle 12">
+            <a:extLst>
+              <a:ext uri="{FF2B5EF4-FFF2-40B4-BE49-F238E27FC236}">
+                <a16:creationId xmlns:a16="http://schemas.microsoft.com/office/drawing/2014/main" id="{448A6892-1A73-B38B-CCF7-E02778CCABDE}"/>
+              </a:ext>
+            </a:extLst>
+          </p:cNvPr>
+          <p:cNvSpPr/>
+          <p:nvPr/>
+        </p:nvSpPr>
+        <p:spPr>
+          <a:xfrm>
+            <a:off x="5928971" y="3950898"/>
+            <a:ext cx="2573546" cy="2880000"/>
+          </a:xfrm>
+          <a:prstGeom prst="rect">
+            <a:avLst/>
+          </a:prstGeom>
+        </p:spPr>
+        <p:style>
+          <a:lnRef idx="2">
+            <a:schemeClr val="accent1">
+              <a:shade val="15000"/>
+            </a:schemeClr>
+          </a:lnRef>
+          <a:fillRef idx="1">
+            <a:schemeClr val="accent1"/>
+          </a:fillRef>
+          <a:effectRef idx="0">
+            <a:schemeClr val="accent1"/>
+          </a:effectRef>
+          <a:fontRef idx="minor">
+            <a:schemeClr val="lt1"/>
+          </a:fontRef>
+        </p:style>
+        <p:txBody>
+          <a:bodyPr rtlCol="0" anchor="ctr"/>
+          <a:lstStyle/>
+          <a:p>
+            <a:pPr algn="ctr"/>
+            <a:r>
+              <a:rPr lang="en-US" dirty="0"/>
+              <a:t>SiO2 = 3 mm</a:t>
+            </a:r>
+            <a:endParaRPr lang="en-GB" dirty="0"/>
+          </a:p>
+        </p:txBody>
+      </p:sp>
+      <p:sp>
+        <p:nvSpPr>
+          <p:cNvPr id="14" name="Rectangle 13">
+            <a:extLst>
+              <a:ext uri="{FF2B5EF4-FFF2-40B4-BE49-F238E27FC236}">
+                <a16:creationId xmlns:a16="http://schemas.microsoft.com/office/drawing/2014/main" id="{3F01A661-1087-494A-1622-6BFFE633ED88}"/>
+              </a:ext>
+            </a:extLst>
+          </p:cNvPr>
+          <p:cNvSpPr/>
+          <p:nvPr/>
+        </p:nvSpPr>
+        <p:spPr>
+          <a:xfrm>
+            <a:off x="5928970" y="3546976"/>
+            <a:ext cx="2573547" cy="194400"/>
+          </a:xfrm>
+          <a:prstGeom prst="rect">
+            <a:avLst/>
+          </a:prstGeom>
+        </p:spPr>
+        <p:style>
+          <a:lnRef idx="2">
+            <a:schemeClr val="accent4">
+              <a:shade val="15000"/>
+            </a:schemeClr>
+          </a:lnRef>
+          <a:fillRef idx="1">
+            <a:schemeClr val="accent4"/>
+          </a:fillRef>
+          <a:effectRef idx="0">
+            <a:schemeClr val="accent4"/>
+          </a:effectRef>
+          <a:fontRef idx="minor">
+            <a:schemeClr val="lt1"/>
+          </a:fontRef>
+        </p:style>
+        <p:txBody>
+          <a:bodyPr rtlCol="0" anchor="ctr"/>
+          <a:lstStyle/>
+          <a:p>
+            <a:pPr algn="ctr"/>
+            <a:r>
+              <a:rPr lang="en-US" sz="1400" dirty="0"/>
+              <a:t>TiO2 = QWOT/2 = 27.14 nm</a:t>
+            </a:r>
+            <a:endParaRPr lang="en-GB" sz="1400" dirty="0"/>
+          </a:p>
+        </p:txBody>
+      </p:sp>
+      <p:sp>
+        <p:nvSpPr>
+          <p:cNvPr id="15" name="Rectangle 14">
+            <a:extLst>
+              <a:ext uri="{FF2B5EF4-FFF2-40B4-BE49-F238E27FC236}">
+                <a16:creationId xmlns:a16="http://schemas.microsoft.com/office/drawing/2014/main" id="{ED93B425-EBF7-8E00-DCA8-85F9D1B37EEB}"/>
+              </a:ext>
+            </a:extLst>
+          </p:cNvPr>
+          <p:cNvSpPr/>
+          <p:nvPr/>
+        </p:nvSpPr>
+        <p:spPr>
+          <a:xfrm>
+            <a:off x="5925069" y="2846657"/>
+            <a:ext cx="2573546" cy="691200"/>
+          </a:xfrm>
+          <a:prstGeom prst="rect">
+            <a:avLst/>
+          </a:prstGeom>
+        </p:spPr>
+        <p:style>
+          <a:lnRef idx="1">
+            <a:schemeClr val="dk1"/>
+          </a:lnRef>
+          <a:fillRef idx="2">
+            <a:schemeClr val="dk1"/>
+          </a:fillRef>
+          <a:effectRef idx="1">
+            <a:schemeClr val="dk1"/>
+          </a:effectRef>
+          <a:fontRef idx="minor">
+            <a:schemeClr val="dk1"/>
+          </a:fontRef>
+        </p:style>
+        <p:txBody>
+          <a:bodyPr rtlCol="0" anchor="ctr"/>
+          <a:lstStyle/>
+          <a:p>
+            <a:pPr algn="ctr"/>
+            <a:r>
+              <a:rPr lang="en-US" sz="1400" dirty="0"/>
+              <a:t>MgF = QWOT = 96.08 nm</a:t>
+            </a:r>
+            <a:endParaRPr lang="en-GB" sz="1400" dirty="0"/>
+          </a:p>
+        </p:txBody>
+      </p:sp>
+      <p:sp>
+        <p:nvSpPr>
+          <p:cNvPr id="16" name="Rectangle 15">
+            <a:extLst>
+              <a:ext uri="{FF2B5EF4-FFF2-40B4-BE49-F238E27FC236}">
+                <a16:creationId xmlns:a16="http://schemas.microsoft.com/office/drawing/2014/main" id="{37278F49-2AA2-8FB9-E1A4-80B7328A89D4}"/>
+              </a:ext>
+            </a:extLst>
+          </p:cNvPr>
+          <p:cNvSpPr/>
+          <p:nvPr/>
+        </p:nvSpPr>
+        <p:spPr>
+          <a:xfrm>
+            <a:off x="5928969" y="2652257"/>
+            <a:ext cx="2573547" cy="194400"/>
+          </a:xfrm>
+          <a:prstGeom prst="rect">
+            <a:avLst/>
+          </a:prstGeom>
+        </p:spPr>
+        <p:style>
+          <a:lnRef idx="2">
+            <a:schemeClr val="accent4">
+              <a:shade val="15000"/>
+            </a:schemeClr>
+          </a:lnRef>
+          <a:fillRef idx="1">
+            <a:schemeClr val="accent4"/>
+          </a:fillRef>
+          <a:effectRef idx="0">
+            <a:schemeClr val="accent4"/>
+          </a:effectRef>
+          <a:fontRef idx="minor">
+            <a:schemeClr val="lt1"/>
+          </a:fontRef>
+        </p:style>
+        <p:txBody>
+          <a:bodyPr rtlCol="0" anchor="ctr"/>
+          <a:lstStyle/>
+          <a:p>
+            <a:pPr algn="ctr"/>
+            <a:r>
+              <a:rPr lang="en-US" sz="1400" dirty="0"/>
+              <a:t>TiO2 = QWOT/2 = 27.14 nm</a:t>
+            </a:r>
+            <a:endParaRPr lang="en-GB" sz="1400" dirty="0"/>
+          </a:p>
+        </p:txBody>
+      </p:sp>
+      <p:sp>
+        <p:nvSpPr>
+          <p:cNvPr id="17" name="Right Brace 16">
+            <a:extLst>
+              <a:ext uri="{FF2B5EF4-FFF2-40B4-BE49-F238E27FC236}">
+                <a16:creationId xmlns:a16="http://schemas.microsoft.com/office/drawing/2014/main" id="{D9E83C76-5758-C5BC-3615-2A7A01A0BC89}"/>
+              </a:ext>
+            </a:extLst>
+          </p:cNvPr>
+          <p:cNvSpPr/>
+          <p:nvPr/>
+        </p:nvSpPr>
+        <p:spPr>
+          <a:xfrm>
+            <a:off x="8502516" y="2852286"/>
+            <a:ext cx="180582" cy="1098611"/>
+          </a:xfrm>
+          <a:prstGeom prst="rightBrace">
+            <a:avLst/>
+          </a:prstGeom>
+        </p:spPr>
+        <p:style>
+          <a:lnRef idx="2">
+            <a:schemeClr val="dk1"/>
+          </a:lnRef>
+          <a:fillRef idx="0">
+            <a:schemeClr val="dk1"/>
+          </a:fillRef>
+          <a:effectRef idx="1">
+            <a:schemeClr val="dk1"/>
+          </a:effectRef>
+          <a:fontRef idx="minor">
+            <a:schemeClr val="tx1"/>
+          </a:fontRef>
+        </p:style>
+        <p:txBody>
+          <a:bodyPr rtlCol="0" anchor="ctr"/>
+          <a:lstStyle/>
+          <a:p>
+            <a:pPr algn="ctr"/>
+            <a:endParaRPr lang="en-GB"/>
+          </a:p>
+        </p:txBody>
+      </p:sp>
+      <p:sp>
+        <p:nvSpPr>
+          <p:cNvPr id="18" name="TextBox 17">
+            <a:extLst>
+              <a:ext uri="{FF2B5EF4-FFF2-40B4-BE49-F238E27FC236}">
+                <a16:creationId xmlns:a16="http://schemas.microsoft.com/office/drawing/2014/main" id="{FCB9A3DF-2527-3629-9C6B-9E2261F04588}"/>
+              </a:ext>
+            </a:extLst>
+          </p:cNvPr>
+          <p:cNvSpPr txBox="1"/>
+          <p:nvPr/>
+        </p:nvSpPr>
+        <p:spPr>
+          <a:xfrm rot="5400000">
+            <a:off x="8250417" y="3244334"/>
+            <a:ext cx="1178464" cy="369332"/>
+          </a:xfrm>
+          <a:prstGeom prst="rect">
+            <a:avLst/>
+          </a:prstGeom>
+          <a:noFill/>
+        </p:spPr>
+        <p:txBody>
+          <a:bodyPr wrap="none" rtlCol="0">
+            <a:spAutoFit/>
+          </a:bodyPr>
+          <a:lstStyle/>
+          <a:p>
+            <a:r>
+              <a:rPr lang="en-US" dirty="0"/>
+              <a:t>1 unit-cell</a:t>
+            </a:r>
+            <a:endParaRPr lang="en-GB" dirty="0"/>
+          </a:p>
+        </p:txBody>
+      </p:sp>
+      <p:sp>
+        <p:nvSpPr>
+          <p:cNvPr id="19" name="TextBox 18">
+            <a:extLst>
+              <a:ext uri="{FF2B5EF4-FFF2-40B4-BE49-F238E27FC236}">
+                <a16:creationId xmlns:a16="http://schemas.microsoft.com/office/drawing/2014/main" id="{BB021161-5093-9C40-F070-292449B9F99A}"/>
+              </a:ext>
+            </a:extLst>
+          </p:cNvPr>
+          <p:cNvSpPr txBox="1"/>
+          <p:nvPr/>
+        </p:nvSpPr>
+        <p:spPr>
+          <a:xfrm>
+            <a:off x="854601" y="1018761"/>
+            <a:ext cx="1431995" cy="369332"/>
+          </a:xfrm>
+          <a:prstGeom prst="rect">
+            <a:avLst/>
+          </a:prstGeom>
+          <a:noFill/>
+        </p:spPr>
+        <p:txBody>
+          <a:bodyPr wrap="none" rtlCol="0">
+            <a:spAutoFit/>
+          </a:bodyPr>
+          <a:lstStyle/>
+          <a:p>
+            <a:r>
+              <a:rPr lang="en-US" b="1" dirty="0"/>
+              <a:t>Single-layer</a:t>
+            </a:r>
+            <a:endParaRPr lang="en-GB" b="1" dirty="0"/>
+          </a:p>
+        </p:txBody>
+      </p:sp>
+      <p:sp>
+        <p:nvSpPr>
+          <p:cNvPr id="20" name="TextBox 19">
+            <a:extLst>
+              <a:ext uri="{FF2B5EF4-FFF2-40B4-BE49-F238E27FC236}">
+                <a16:creationId xmlns:a16="http://schemas.microsoft.com/office/drawing/2014/main" id="{5532BE08-2760-40DD-1C01-8FDF891B92EC}"/>
+              </a:ext>
+            </a:extLst>
+          </p:cNvPr>
+          <p:cNvSpPr txBox="1"/>
+          <p:nvPr/>
+        </p:nvSpPr>
+        <p:spPr>
+          <a:xfrm>
+            <a:off x="6096000" y="888568"/>
+            <a:ext cx="2195216" cy="923330"/>
+          </a:xfrm>
+          <a:prstGeom prst="rect">
+            <a:avLst/>
+          </a:prstGeom>
+          <a:noFill/>
+        </p:spPr>
+        <p:txBody>
+          <a:bodyPr wrap="none" rtlCol="0">
+            <a:spAutoFit/>
+          </a:bodyPr>
+          <a:lstStyle/>
+          <a:p>
+            <a:r>
+              <a:rPr lang="en-US" b="1" dirty="0"/>
+              <a:t>Fabry-Perot </a:t>
+            </a:r>
+          </a:p>
+          <a:p>
+            <a:r>
+              <a:rPr lang="en-US" dirty="0"/>
+              <a:t>N=1(MgF/SbSe) M=0</a:t>
+            </a:r>
+          </a:p>
+          <a:p>
+            <a:r>
+              <a:rPr lang="en-US" dirty="0"/>
+              <a:t>H = TiO2, L = MgF2</a:t>
+            </a:r>
+            <a:endParaRPr lang="en-GB" dirty="0"/>
+          </a:p>
+        </p:txBody>
+      </p:sp>
+      <p:sp>
+        <p:nvSpPr>
+          <p:cNvPr id="21" name="Rectangle 20">
+            <a:extLst>
+              <a:ext uri="{FF2B5EF4-FFF2-40B4-BE49-F238E27FC236}">
+                <a16:creationId xmlns:a16="http://schemas.microsoft.com/office/drawing/2014/main" id="{B8BAB0C7-4C4C-31A5-16F1-E8E4E51A02E2}"/>
+              </a:ext>
+            </a:extLst>
+          </p:cNvPr>
+          <p:cNvSpPr/>
+          <p:nvPr/>
+        </p:nvSpPr>
+        <p:spPr>
+          <a:xfrm>
+            <a:off x="9159527" y="3946279"/>
+            <a:ext cx="2573546" cy="2896093"/>
+          </a:xfrm>
+          <a:prstGeom prst="rect">
+            <a:avLst/>
+          </a:prstGeom>
+        </p:spPr>
+        <p:style>
+          <a:lnRef idx="2">
+            <a:schemeClr val="accent1">
+              <a:shade val="15000"/>
+            </a:schemeClr>
+          </a:lnRef>
+          <a:fillRef idx="1">
+            <a:schemeClr val="accent1"/>
+          </a:fillRef>
+          <a:effectRef idx="0">
+            <a:schemeClr val="accent1"/>
+          </a:effectRef>
+          <a:fontRef idx="minor">
+            <a:schemeClr val="lt1"/>
+          </a:fontRef>
+        </p:style>
+        <p:txBody>
+          <a:bodyPr rtlCol="0" anchor="ctr"/>
+          <a:lstStyle/>
+          <a:p>
+            <a:pPr algn="ctr"/>
+            <a:r>
+              <a:rPr lang="en-US" dirty="0"/>
+              <a:t>SiO2 = 3 mm</a:t>
+            </a:r>
+            <a:endParaRPr lang="en-GB" dirty="0"/>
+          </a:p>
+        </p:txBody>
+      </p:sp>
+      <p:sp>
+        <p:nvSpPr>
+          <p:cNvPr id="26" name="TextBox 25">
+            <a:extLst>
+              <a:ext uri="{FF2B5EF4-FFF2-40B4-BE49-F238E27FC236}">
+                <a16:creationId xmlns:a16="http://schemas.microsoft.com/office/drawing/2014/main" id="{3B53EC74-B799-1810-3AF5-6A595A55A58F}"/>
+              </a:ext>
+            </a:extLst>
+          </p:cNvPr>
+          <p:cNvSpPr txBox="1"/>
+          <p:nvPr/>
+        </p:nvSpPr>
+        <p:spPr>
+          <a:xfrm rot="5400000">
+            <a:off x="11452984" y="3035119"/>
+            <a:ext cx="1290674" cy="369332"/>
+          </a:xfrm>
+          <a:prstGeom prst="rect">
+            <a:avLst/>
+          </a:prstGeom>
+          <a:noFill/>
+        </p:spPr>
+        <p:txBody>
+          <a:bodyPr wrap="none" rtlCol="0">
+            <a:spAutoFit/>
+          </a:bodyPr>
+          <a:lstStyle/>
+          <a:p>
+            <a:r>
+              <a:rPr lang="en-US" dirty="0"/>
+              <a:t>1 unit-cells</a:t>
+            </a:r>
+            <a:endParaRPr lang="en-GB" dirty="0"/>
+          </a:p>
+        </p:txBody>
+      </p:sp>
+      <p:sp>
+        <p:nvSpPr>
+          <p:cNvPr id="8" name="Title 1">
+            <a:extLst>
+              <a:ext uri="{FF2B5EF4-FFF2-40B4-BE49-F238E27FC236}">
+                <a16:creationId xmlns:a16="http://schemas.microsoft.com/office/drawing/2014/main" id="{9E5ED80B-FEF2-C389-54E1-58A49645242E}"/>
+              </a:ext>
+            </a:extLst>
+          </p:cNvPr>
+          <p:cNvSpPr txBox="1">
+            <a:spLocks/>
+          </p:cNvSpPr>
+          <p:nvPr/>
+        </p:nvSpPr>
+        <p:spPr>
+          <a:xfrm>
+            <a:off x="-3696" y="-4206"/>
+            <a:ext cx="5587200" cy="892774"/>
+          </a:xfrm>
+          <a:prstGeom prst="rect">
+            <a:avLst/>
+          </a:prstGeom>
+          <a:solidFill>
+            <a:schemeClr val="accent6"/>
+          </a:solidFill>
+        </p:spPr>
+        <p:txBody>
+          <a:bodyPr vert="horz" lIns="91440" tIns="45720" rIns="91440" bIns="45720" rtlCol="0" anchor="ctr">
+            <a:normAutofit/>
+          </a:bodyPr>
+          <a:lstStyle>
+            <a:lvl1pPr algn="l" defTabSz="914400" rtl="0" eaLnBrk="1" latinLnBrk="0" hangingPunct="1">
+              <a:lnSpc>
+                <a:spcPct val="90000"/>
+              </a:lnSpc>
+              <a:spcBef>
+                <a:spcPct val="0"/>
+              </a:spcBef>
+              <a:buNone/>
+              <a:defRPr sz="4400" kern="1200">
+                <a:solidFill>
+                  <a:schemeClr val="tx1"/>
+                </a:solidFill>
+                <a:latin typeface="+mj-lt"/>
+                <a:ea typeface="+mj-ea"/>
+                <a:cs typeface="+mj-cs"/>
+              </a:defRPr>
+            </a:lvl1pPr>
+          </a:lstStyle>
+          <a:p>
+            <a:r>
+              <a:rPr lang="en-US" dirty="0"/>
+              <a:t>532 nm Optical limiter</a:t>
+            </a:r>
+            <a:endParaRPr lang="en-GB" dirty="0"/>
+          </a:p>
+        </p:txBody>
+      </p:sp>
+      <p:sp>
+        <p:nvSpPr>
+          <p:cNvPr id="10" name="TextBox 9">
+            <a:extLst>
+              <a:ext uri="{FF2B5EF4-FFF2-40B4-BE49-F238E27FC236}">
+                <a16:creationId xmlns:a16="http://schemas.microsoft.com/office/drawing/2014/main" id="{BA955E56-6E44-FD6C-3379-710335A1BAAE}"/>
+              </a:ext>
+            </a:extLst>
+          </p:cNvPr>
+          <p:cNvSpPr txBox="1"/>
+          <p:nvPr/>
+        </p:nvSpPr>
+        <p:spPr>
+          <a:xfrm>
+            <a:off x="3070656" y="589933"/>
+            <a:ext cx="3481787" cy="369332"/>
+          </a:xfrm>
+          <a:prstGeom prst="rect">
+            <a:avLst/>
+          </a:prstGeom>
+          <a:noFill/>
+        </p:spPr>
+        <p:txBody>
+          <a:bodyPr wrap="none" rtlCol="0">
+            <a:spAutoFit/>
+          </a:bodyPr>
+          <a:lstStyle/>
+          <a:p>
+            <a:r>
+              <a:rPr lang="en-US" b="1" dirty="0">
+                <a:highlight>
+                  <a:srgbClr val="FF0000"/>
+                </a:highlight>
+              </a:rPr>
+              <a:t>Reference wavelength = 532 nm</a:t>
+            </a:r>
+            <a:endParaRPr lang="en-GB" b="1" dirty="0">
+              <a:highlight>
+                <a:srgbClr val="FF0000"/>
+              </a:highlight>
+            </a:endParaRPr>
+          </a:p>
+        </p:txBody>
+      </p:sp>
+      <p:sp>
+        <p:nvSpPr>
+          <p:cNvPr id="11" name="Rectangle 10">
+            <a:extLst>
+              <a:ext uri="{FF2B5EF4-FFF2-40B4-BE49-F238E27FC236}">
+                <a16:creationId xmlns:a16="http://schemas.microsoft.com/office/drawing/2014/main" id="{003EBD3A-320C-CD97-72B7-0C0A7CD27FA3}"/>
+              </a:ext>
+            </a:extLst>
+          </p:cNvPr>
+          <p:cNvSpPr/>
+          <p:nvPr/>
+        </p:nvSpPr>
+        <p:spPr>
+          <a:xfrm>
+            <a:off x="5928516" y="2083478"/>
+            <a:ext cx="2574000" cy="180000"/>
+          </a:xfrm>
+          <a:prstGeom prst="rect">
+            <a:avLst/>
+          </a:prstGeom>
+        </p:spPr>
+        <p:style>
+          <a:lnRef idx="2">
+            <a:schemeClr val="accent3">
+              <a:shade val="15000"/>
+            </a:schemeClr>
+          </a:lnRef>
+          <a:fillRef idx="1">
+            <a:schemeClr val="accent3"/>
+          </a:fillRef>
+          <a:effectRef idx="0">
+            <a:schemeClr val="accent3"/>
+          </a:effectRef>
+          <a:fontRef idx="minor">
+            <a:schemeClr val="lt1"/>
+          </a:fontRef>
+        </p:style>
+        <p:txBody>
+          <a:bodyPr rtlCol="0" anchor="ctr"/>
+          <a:lstStyle/>
+          <a:p>
+            <a:pPr algn="ctr"/>
+            <a:r>
+              <a:rPr lang="en-US" sz="1400" dirty="0"/>
+              <a:t>SbSe = 6.6 nm</a:t>
+            </a:r>
+            <a:endParaRPr lang="en-GB" sz="1400" dirty="0"/>
+          </a:p>
+        </p:txBody>
+      </p:sp>
+      <p:sp>
+        <p:nvSpPr>
+          <p:cNvPr id="12" name="Rectangle 11">
+            <a:extLst>
+              <a:ext uri="{FF2B5EF4-FFF2-40B4-BE49-F238E27FC236}">
+                <a16:creationId xmlns:a16="http://schemas.microsoft.com/office/drawing/2014/main" id="{A77DF160-55E2-FF78-F55D-B4DDD13D2CFD}"/>
+              </a:ext>
+            </a:extLst>
+          </p:cNvPr>
+          <p:cNvSpPr/>
+          <p:nvPr/>
+        </p:nvSpPr>
+        <p:spPr>
+          <a:xfrm>
+            <a:off x="5928969" y="2270678"/>
+            <a:ext cx="2573546" cy="367200"/>
+          </a:xfrm>
+          <a:prstGeom prst="rect">
+            <a:avLst/>
+          </a:prstGeom>
+        </p:spPr>
+        <p:style>
+          <a:lnRef idx="1">
+            <a:schemeClr val="dk1"/>
+          </a:lnRef>
+          <a:fillRef idx="2">
+            <a:schemeClr val="dk1"/>
+          </a:fillRef>
+          <a:effectRef idx="1">
+            <a:schemeClr val="dk1"/>
+          </a:effectRef>
+          <a:fontRef idx="minor">
+            <a:schemeClr val="dk1"/>
+          </a:fontRef>
+        </p:style>
+        <p:txBody>
+          <a:bodyPr rtlCol="0" anchor="ctr"/>
+          <a:lstStyle/>
+          <a:p>
+            <a:pPr algn="ctr"/>
+            <a:r>
+              <a:rPr lang="en-US" sz="1400" dirty="0"/>
+              <a:t>MgF = 51.4 nm</a:t>
+            </a:r>
+            <a:endParaRPr lang="en-GB" sz="1400" dirty="0"/>
+          </a:p>
+        </p:txBody>
+      </p:sp>
+      <p:sp>
+        <p:nvSpPr>
+          <p:cNvPr id="31" name="Rectangle 30">
+            <a:extLst>
+              <a:ext uri="{FF2B5EF4-FFF2-40B4-BE49-F238E27FC236}">
+                <a16:creationId xmlns:a16="http://schemas.microsoft.com/office/drawing/2014/main" id="{03433DFC-0F4B-4AE6-25C6-B0CE15FA0889}"/>
+              </a:ext>
+            </a:extLst>
+          </p:cNvPr>
+          <p:cNvSpPr/>
+          <p:nvPr/>
+        </p:nvSpPr>
+        <p:spPr>
+          <a:xfrm>
+            <a:off x="9159528" y="3558124"/>
+            <a:ext cx="2573547" cy="194400"/>
+          </a:xfrm>
+          <a:prstGeom prst="rect">
+            <a:avLst/>
+          </a:prstGeom>
+        </p:spPr>
+        <p:style>
+          <a:lnRef idx="2">
+            <a:schemeClr val="accent4">
+              <a:shade val="15000"/>
+            </a:schemeClr>
+          </a:lnRef>
+          <a:fillRef idx="1">
+            <a:schemeClr val="accent4"/>
+          </a:fillRef>
+          <a:effectRef idx="0">
+            <a:schemeClr val="accent4"/>
+          </a:effectRef>
+          <a:fontRef idx="minor">
+            <a:schemeClr val="lt1"/>
+          </a:fontRef>
+        </p:style>
+        <p:txBody>
+          <a:bodyPr rtlCol="0" anchor="ctr"/>
+          <a:lstStyle/>
+          <a:p>
+            <a:pPr algn="ctr"/>
+            <a:r>
+              <a:rPr lang="en-US" sz="1400" dirty="0"/>
+              <a:t>TiO2 = QWOT/2 = 27.14 nm</a:t>
+            </a:r>
+            <a:endParaRPr lang="en-GB" sz="1400" dirty="0"/>
+          </a:p>
+        </p:txBody>
+      </p:sp>
+      <p:sp>
+        <p:nvSpPr>
+          <p:cNvPr id="32" name="Rectangle 31">
+            <a:extLst>
+              <a:ext uri="{FF2B5EF4-FFF2-40B4-BE49-F238E27FC236}">
+                <a16:creationId xmlns:a16="http://schemas.microsoft.com/office/drawing/2014/main" id="{D741448D-72D6-466E-1178-F219B9AD001D}"/>
+              </a:ext>
+            </a:extLst>
+          </p:cNvPr>
+          <p:cNvSpPr/>
+          <p:nvPr/>
+        </p:nvSpPr>
+        <p:spPr>
+          <a:xfrm>
+            <a:off x="9155627" y="2857805"/>
+            <a:ext cx="2573546" cy="691200"/>
+          </a:xfrm>
+          <a:prstGeom prst="rect">
+            <a:avLst/>
+          </a:prstGeom>
+        </p:spPr>
+        <p:style>
+          <a:lnRef idx="1">
+            <a:schemeClr val="dk1"/>
+          </a:lnRef>
+          <a:fillRef idx="2">
+            <a:schemeClr val="dk1"/>
+          </a:fillRef>
+          <a:effectRef idx="1">
+            <a:schemeClr val="dk1"/>
+          </a:effectRef>
+          <a:fontRef idx="minor">
+            <a:schemeClr val="dk1"/>
+          </a:fontRef>
+        </p:style>
+        <p:txBody>
+          <a:bodyPr rtlCol="0" anchor="ctr"/>
+          <a:lstStyle/>
+          <a:p>
+            <a:pPr algn="ctr"/>
+            <a:r>
+              <a:rPr lang="en-US" sz="1400" dirty="0"/>
+              <a:t>MgF = QWOT = 96.08 nm</a:t>
+            </a:r>
+            <a:endParaRPr lang="en-GB" sz="1400" dirty="0"/>
+          </a:p>
+        </p:txBody>
+      </p:sp>
+      <p:sp>
+        <p:nvSpPr>
+          <p:cNvPr id="33" name="Rectangle 32">
+            <a:extLst>
+              <a:ext uri="{FF2B5EF4-FFF2-40B4-BE49-F238E27FC236}">
+                <a16:creationId xmlns:a16="http://schemas.microsoft.com/office/drawing/2014/main" id="{6A247982-112D-BF39-C4C7-3816DF63372E}"/>
+              </a:ext>
+            </a:extLst>
+          </p:cNvPr>
+          <p:cNvSpPr/>
+          <p:nvPr/>
+        </p:nvSpPr>
+        <p:spPr>
+          <a:xfrm>
+            <a:off x="9159527" y="2663405"/>
+            <a:ext cx="2573547" cy="194400"/>
+          </a:xfrm>
+          <a:prstGeom prst="rect">
+            <a:avLst/>
+          </a:prstGeom>
+        </p:spPr>
+        <p:style>
+          <a:lnRef idx="2">
+            <a:schemeClr val="accent4">
+              <a:shade val="15000"/>
+            </a:schemeClr>
+          </a:lnRef>
+          <a:fillRef idx="1">
+            <a:schemeClr val="accent4"/>
+          </a:fillRef>
+          <a:effectRef idx="0">
+            <a:schemeClr val="accent4"/>
+          </a:effectRef>
+          <a:fontRef idx="minor">
+            <a:schemeClr val="lt1"/>
+          </a:fontRef>
+        </p:style>
+        <p:txBody>
+          <a:bodyPr rtlCol="0" anchor="ctr"/>
+          <a:lstStyle/>
+          <a:p>
+            <a:pPr algn="ctr"/>
+            <a:r>
+              <a:rPr lang="en-US" sz="1400" dirty="0"/>
+              <a:t>TiO2 = QWOT/2 = 27.14 nm</a:t>
+            </a:r>
+            <a:endParaRPr lang="en-GB" sz="1400" dirty="0"/>
+          </a:p>
+        </p:txBody>
+      </p:sp>
+      <p:sp>
+        <p:nvSpPr>
+          <p:cNvPr id="34" name="Right Brace 33">
+            <a:extLst>
+              <a:ext uri="{FF2B5EF4-FFF2-40B4-BE49-F238E27FC236}">
+                <a16:creationId xmlns:a16="http://schemas.microsoft.com/office/drawing/2014/main" id="{775BDE89-B541-F2AD-F5F5-75DFB764BD70}"/>
+              </a:ext>
+            </a:extLst>
+          </p:cNvPr>
+          <p:cNvSpPr/>
+          <p:nvPr/>
+        </p:nvSpPr>
+        <p:spPr>
+          <a:xfrm>
+            <a:off x="11733074" y="2678145"/>
+            <a:ext cx="236812" cy="1083280"/>
+          </a:xfrm>
+          <a:prstGeom prst="rightBrace">
+            <a:avLst/>
+          </a:prstGeom>
+        </p:spPr>
+        <p:style>
+          <a:lnRef idx="2">
+            <a:schemeClr val="dk1"/>
+          </a:lnRef>
+          <a:fillRef idx="0">
+            <a:schemeClr val="dk1"/>
+          </a:fillRef>
+          <a:effectRef idx="1">
+            <a:schemeClr val="dk1"/>
+          </a:effectRef>
+          <a:fontRef idx="minor">
+            <a:schemeClr val="tx1"/>
+          </a:fontRef>
+        </p:style>
+        <p:txBody>
+          <a:bodyPr rtlCol="0" anchor="ctr"/>
+          <a:lstStyle/>
+          <a:p>
+            <a:pPr algn="ctr"/>
+            <a:endParaRPr lang="en-GB"/>
+          </a:p>
+        </p:txBody>
+      </p:sp>
+      <p:sp>
+        <p:nvSpPr>
+          <p:cNvPr id="41" name="Rectangle 40">
+            <a:extLst>
+              <a:ext uri="{FF2B5EF4-FFF2-40B4-BE49-F238E27FC236}">
+                <a16:creationId xmlns:a16="http://schemas.microsoft.com/office/drawing/2014/main" id="{83D751A7-05F5-1295-631E-56DAE709159A}"/>
+              </a:ext>
+            </a:extLst>
+          </p:cNvPr>
+          <p:cNvSpPr/>
+          <p:nvPr/>
+        </p:nvSpPr>
+        <p:spPr>
+          <a:xfrm>
+            <a:off x="5924244" y="3756498"/>
+            <a:ext cx="2573547" cy="194400"/>
+          </a:xfrm>
+          <a:prstGeom prst="rect">
+            <a:avLst/>
+          </a:prstGeom>
+        </p:spPr>
+        <p:style>
+          <a:lnRef idx="2">
+            <a:schemeClr val="accent4">
+              <a:shade val="15000"/>
+            </a:schemeClr>
+          </a:lnRef>
+          <a:fillRef idx="1">
+            <a:schemeClr val="accent4"/>
+          </a:fillRef>
+          <a:effectRef idx="0">
+            <a:schemeClr val="accent4"/>
+          </a:effectRef>
+          <a:fontRef idx="minor">
+            <a:schemeClr val="lt1"/>
+          </a:fontRef>
+        </p:style>
+        <p:txBody>
+          <a:bodyPr rtlCol="0" anchor="ctr"/>
+          <a:lstStyle/>
+          <a:p>
+            <a:pPr algn="ctr"/>
+            <a:r>
+              <a:rPr lang="en-US" sz="1400" dirty="0"/>
+              <a:t>TiO2 = QWOT/2 = 27.14 nm</a:t>
+            </a:r>
+            <a:endParaRPr lang="en-GB" sz="1400" dirty="0"/>
+          </a:p>
+        </p:txBody>
+      </p:sp>
+      <p:sp>
+        <p:nvSpPr>
+          <p:cNvPr id="42" name="Rectangle 41">
+            <a:extLst>
+              <a:ext uri="{FF2B5EF4-FFF2-40B4-BE49-F238E27FC236}">
+                <a16:creationId xmlns:a16="http://schemas.microsoft.com/office/drawing/2014/main" id="{EAEEA93F-CC51-6379-15B3-62FC6B3A0478}"/>
+              </a:ext>
+            </a:extLst>
+          </p:cNvPr>
+          <p:cNvSpPr/>
+          <p:nvPr/>
+        </p:nvSpPr>
+        <p:spPr>
+          <a:xfrm>
+            <a:off x="5924243" y="1890441"/>
+            <a:ext cx="2573547" cy="194400"/>
+          </a:xfrm>
+          <a:prstGeom prst="rect">
+            <a:avLst/>
+          </a:prstGeom>
+        </p:spPr>
+        <p:style>
+          <a:lnRef idx="2">
+            <a:schemeClr val="accent4">
+              <a:shade val="15000"/>
+            </a:schemeClr>
+          </a:lnRef>
+          <a:fillRef idx="1">
+            <a:schemeClr val="accent4"/>
+          </a:fillRef>
+          <a:effectRef idx="0">
+            <a:schemeClr val="accent4"/>
+          </a:effectRef>
+          <a:fontRef idx="minor">
+            <a:schemeClr val="lt1"/>
+          </a:fontRef>
+        </p:style>
+        <p:txBody>
+          <a:bodyPr rtlCol="0" anchor="ctr"/>
+          <a:lstStyle/>
+          <a:p>
+            <a:pPr algn="ctr"/>
+            <a:r>
+              <a:rPr lang="en-US" sz="1400" dirty="0"/>
+              <a:t>TiO2 = QWOT/2 = 27.14 nm</a:t>
+            </a:r>
+            <a:endParaRPr lang="en-GB" sz="1400" dirty="0"/>
+          </a:p>
+        </p:txBody>
+      </p:sp>
+      <p:sp>
+        <p:nvSpPr>
+          <p:cNvPr id="43" name="Rectangle 42">
+            <a:extLst>
+              <a:ext uri="{FF2B5EF4-FFF2-40B4-BE49-F238E27FC236}">
+                <a16:creationId xmlns:a16="http://schemas.microsoft.com/office/drawing/2014/main" id="{FAE82B61-4EC9-7DA0-EA89-2DE4E69C9380}"/>
+              </a:ext>
+            </a:extLst>
+          </p:cNvPr>
+          <p:cNvSpPr/>
+          <p:nvPr/>
+        </p:nvSpPr>
+        <p:spPr>
+          <a:xfrm>
+            <a:off x="9163428" y="3752524"/>
+            <a:ext cx="2573547" cy="194400"/>
+          </a:xfrm>
+          <a:prstGeom prst="rect">
+            <a:avLst/>
+          </a:prstGeom>
+        </p:spPr>
+        <p:style>
+          <a:lnRef idx="2">
+            <a:schemeClr val="accent4">
+              <a:shade val="15000"/>
+            </a:schemeClr>
+          </a:lnRef>
+          <a:fillRef idx="1">
+            <a:schemeClr val="accent4"/>
+          </a:fillRef>
+          <a:effectRef idx="0">
+            <a:schemeClr val="accent4"/>
+          </a:effectRef>
+          <a:fontRef idx="minor">
+            <a:schemeClr val="lt1"/>
+          </a:fontRef>
+        </p:style>
+        <p:txBody>
+          <a:bodyPr rtlCol="0" anchor="ctr"/>
+          <a:lstStyle/>
+          <a:p>
+            <a:pPr algn="ctr"/>
+            <a:r>
+              <a:rPr lang="en-US" sz="1400" dirty="0"/>
+              <a:t>TiO2 = QWOT/2 = 27.14 nm</a:t>
+            </a:r>
+            <a:endParaRPr lang="en-GB" sz="1400" dirty="0"/>
+          </a:p>
+        </p:txBody>
+      </p:sp>
+      <p:sp>
+        <p:nvSpPr>
+          <p:cNvPr id="44" name="Rectangle 43">
+            <a:extLst>
+              <a:ext uri="{FF2B5EF4-FFF2-40B4-BE49-F238E27FC236}">
+                <a16:creationId xmlns:a16="http://schemas.microsoft.com/office/drawing/2014/main" id="{04139779-49EF-186B-7C2E-45D4B7A50035}"/>
+              </a:ext>
+            </a:extLst>
+          </p:cNvPr>
+          <p:cNvSpPr/>
+          <p:nvPr/>
+        </p:nvSpPr>
+        <p:spPr>
+          <a:xfrm>
+            <a:off x="9164201" y="2477906"/>
+            <a:ext cx="2574000" cy="180000"/>
+          </a:xfrm>
+          <a:prstGeom prst="rect">
+            <a:avLst/>
+          </a:prstGeom>
+        </p:spPr>
+        <p:style>
+          <a:lnRef idx="2">
+            <a:schemeClr val="accent3">
+              <a:shade val="15000"/>
+            </a:schemeClr>
+          </a:lnRef>
+          <a:fillRef idx="1">
+            <a:schemeClr val="accent3"/>
+          </a:fillRef>
+          <a:effectRef idx="0">
+            <a:schemeClr val="accent3"/>
+          </a:effectRef>
+          <a:fontRef idx="minor">
+            <a:schemeClr val="lt1"/>
+          </a:fontRef>
+        </p:style>
+        <p:txBody>
+          <a:bodyPr rtlCol="0" anchor="ctr"/>
+          <a:lstStyle/>
+          <a:p>
+            <a:pPr algn="ctr"/>
+            <a:r>
+              <a:rPr lang="en-US" sz="1400" dirty="0"/>
+              <a:t>SbSe = 7.1 nm</a:t>
+            </a:r>
+            <a:endParaRPr lang="en-GB" sz="1400" dirty="0"/>
+          </a:p>
+        </p:txBody>
+      </p:sp>
+      <p:sp>
+        <p:nvSpPr>
+          <p:cNvPr id="46" name="Rectangle 45">
+            <a:extLst>
+              <a:ext uri="{FF2B5EF4-FFF2-40B4-BE49-F238E27FC236}">
+                <a16:creationId xmlns:a16="http://schemas.microsoft.com/office/drawing/2014/main" id="{22A85780-C71F-447C-434D-54B9A3634A81}"/>
+              </a:ext>
+            </a:extLst>
+          </p:cNvPr>
+          <p:cNvSpPr/>
+          <p:nvPr/>
+        </p:nvSpPr>
+        <p:spPr>
+          <a:xfrm>
+            <a:off x="9163428" y="2272492"/>
+            <a:ext cx="2573547" cy="194400"/>
+          </a:xfrm>
+          <a:prstGeom prst="rect">
+            <a:avLst/>
+          </a:prstGeom>
+        </p:spPr>
+        <p:style>
+          <a:lnRef idx="2">
+            <a:schemeClr val="accent4">
+              <a:shade val="15000"/>
+            </a:schemeClr>
+          </a:lnRef>
+          <a:fillRef idx="1">
+            <a:schemeClr val="accent4"/>
+          </a:fillRef>
+          <a:effectRef idx="0">
+            <a:schemeClr val="accent4"/>
+          </a:effectRef>
+          <a:fontRef idx="minor">
+            <a:schemeClr val="lt1"/>
+          </a:fontRef>
+        </p:style>
+        <p:txBody>
+          <a:bodyPr rtlCol="0" anchor="ctr"/>
+          <a:lstStyle/>
+          <a:p>
+            <a:pPr algn="ctr"/>
+            <a:r>
+              <a:rPr lang="en-US" sz="1400" dirty="0"/>
+              <a:t>TiO2  = 34.6 nm</a:t>
+            </a:r>
+            <a:endParaRPr lang="en-GB" sz="1400" dirty="0"/>
+          </a:p>
+        </p:txBody>
+      </p:sp>
+      <p:sp>
+        <p:nvSpPr>
+          <p:cNvPr id="47" name="Rectangle 46">
+            <a:extLst>
+              <a:ext uri="{FF2B5EF4-FFF2-40B4-BE49-F238E27FC236}">
+                <a16:creationId xmlns:a16="http://schemas.microsoft.com/office/drawing/2014/main" id="{27D83077-A2C2-E8E3-9652-AD8EF559AEFE}"/>
+              </a:ext>
+            </a:extLst>
+          </p:cNvPr>
+          <p:cNvSpPr/>
+          <p:nvPr/>
+        </p:nvSpPr>
+        <p:spPr>
+          <a:xfrm>
+            <a:off x="9162974" y="2077813"/>
+            <a:ext cx="2574000" cy="180000"/>
+          </a:xfrm>
+          <a:prstGeom prst="rect">
+            <a:avLst/>
+          </a:prstGeom>
+        </p:spPr>
+        <p:style>
+          <a:lnRef idx="2">
+            <a:schemeClr val="accent3">
+              <a:shade val="15000"/>
+            </a:schemeClr>
+          </a:lnRef>
+          <a:fillRef idx="1">
+            <a:schemeClr val="accent3"/>
+          </a:fillRef>
+          <a:effectRef idx="0">
+            <a:schemeClr val="accent3"/>
+          </a:effectRef>
+          <a:fontRef idx="minor">
+            <a:schemeClr val="lt1"/>
+          </a:fontRef>
+        </p:style>
+        <p:txBody>
+          <a:bodyPr rtlCol="0" anchor="ctr"/>
+          <a:lstStyle/>
+          <a:p>
+            <a:pPr algn="ctr"/>
+            <a:r>
+              <a:rPr lang="en-US" sz="1400" dirty="0"/>
+              <a:t>SbSe = 7.1 nm</a:t>
+            </a:r>
+            <a:endParaRPr lang="en-GB" sz="1400" dirty="0"/>
+          </a:p>
+        </p:txBody>
+      </p:sp>
+      <p:sp>
+        <p:nvSpPr>
+          <p:cNvPr id="48" name="Rectangle 47">
+            <a:extLst>
+              <a:ext uri="{FF2B5EF4-FFF2-40B4-BE49-F238E27FC236}">
+                <a16:creationId xmlns:a16="http://schemas.microsoft.com/office/drawing/2014/main" id="{954FA874-D004-E915-7288-5478D546887E}"/>
+              </a:ext>
+            </a:extLst>
+          </p:cNvPr>
+          <p:cNvSpPr/>
+          <p:nvPr/>
+        </p:nvSpPr>
+        <p:spPr>
+          <a:xfrm>
+            <a:off x="9163427" y="1866839"/>
+            <a:ext cx="2573547" cy="194400"/>
+          </a:xfrm>
+          <a:prstGeom prst="rect">
+            <a:avLst/>
+          </a:prstGeom>
+        </p:spPr>
+        <p:style>
+          <a:lnRef idx="2">
+            <a:schemeClr val="accent4">
+              <a:shade val="15000"/>
+            </a:schemeClr>
+          </a:lnRef>
+          <a:fillRef idx="1">
+            <a:schemeClr val="accent4"/>
+          </a:fillRef>
+          <a:effectRef idx="0">
+            <a:schemeClr val="accent4"/>
+          </a:effectRef>
+          <a:fontRef idx="minor">
+            <a:schemeClr val="lt1"/>
+          </a:fontRef>
+        </p:style>
+        <p:txBody>
+          <a:bodyPr rtlCol="0" anchor="ctr"/>
+          <a:lstStyle/>
+          <a:p>
+            <a:pPr algn="ctr"/>
+            <a:r>
+              <a:rPr lang="en-US" sz="1400" dirty="0"/>
+              <a:t>TiO2 = QWOT/2 = 27.14 nm</a:t>
+            </a:r>
+            <a:endParaRPr lang="en-GB" sz="1400" dirty="0"/>
+          </a:p>
+        </p:txBody>
+      </p:sp>
+      <p:sp>
+        <p:nvSpPr>
+          <p:cNvPr id="51" name="Rectangle 50">
+            <a:extLst>
+              <a:ext uri="{FF2B5EF4-FFF2-40B4-BE49-F238E27FC236}">
+                <a16:creationId xmlns:a16="http://schemas.microsoft.com/office/drawing/2014/main" id="{4D4D6E3C-A066-0A6B-BAB1-4A66C4FC29BB}"/>
+              </a:ext>
+            </a:extLst>
+          </p:cNvPr>
+          <p:cNvSpPr/>
+          <p:nvPr/>
+        </p:nvSpPr>
+        <p:spPr>
+          <a:xfrm>
+            <a:off x="3037141" y="3962372"/>
+            <a:ext cx="2574000" cy="2880000"/>
+          </a:xfrm>
+          <a:prstGeom prst="rect">
+            <a:avLst/>
+          </a:prstGeom>
+        </p:spPr>
+        <p:style>
+          <a:lnRef idx="2">
+            <a:schemeClr val="accent1">
+              <a:shade val="15000"/>
+            </a:schemeClr>
+          </a:lnRef>
+          <a:fillRef idx="1">
+            <a:schemeClr val="accent1"/>
+          </a:fillRef>
+          <a:effectRef idx="0">
+            <a:schemeClr val="accent1"/>
+          </a:effectRef>
+          <a:fontRef idx="minor">
+            <a:schemeClr val="lt1"/>
+          </a:fontRef>
+        </p:style>
+        <p:txBody>
+          <a:bodyPr rtlCol="0" anchor="ctr"/>
+          <a:lstStyle/>
+          <a:p>
+            <a:pPr algn="ctr"/>
+            <a:r>
+              <a:rPr lang="en-US" dirty="0"/>
+              <a:t>SiO2 = 3 mm</a:t>
+            </a:r>
+            <a:endParaRPr lang="en-GB" dirty="0"/>
+          </a:p>
+        </p:txBody>
+      </p:sp>
+      <p:sp>
+        <p:nvSpPr>
+          <p:cNvPr id="53" name="TextBox 52">
+            <a:extLst>
+              <a:ext uri="{FF2B5EF4-FFF2-40B4-BE49-F238E27FC236}">
+                <a16:creationId xmlns:a16="http://schemas.microsoft.com/office/drawing/2014/main" id="{9435FC76-C852-83D1-8C2D-22C407E9F127}"/>
+              </a:ext>
+            </a:extLst>
+          </p:cNvPr>
+          <p:cNvSpPr txBox="1"/>
+          <p:nvPr/>
+        </p:nvSpPr>
+        <p:spPr>
+          <a:xfrm>
+            <a:off x="3648764" y="1010208"/>
+            <a:ext cx="1431995" cy="646331"/>
+          </a:xfrm>
+          <a:prstGeom prst="rect">
+            <a:avLst/>
+          </a:prstGeom>
+          <a:noFill/>
+        </p:spPr>
+        <p:txBody>
+          <a:bodyPr wrap="none" rtlCol="0">
+            <a:spAutoFit/>
+          </a:bodyPr>
+          <a:lstStyle/>
+          <a:p>
+            <a:r>
+              <a:rPr lang="en-US" b="1" dirty="0"/>
+              <a:t>Single-layer</a:t>
+            </a:r>
+          </a:p>
+          <a:p>
+            <a:r>
+              <a:rPr lang="en-US" b="1" dirty="0"/>
+              <a:t>(non QWOT)</a:t>
+            </a:r>
+            <a:endParaRPr lang="en-GB" b="1" dirty="0"/>
+          </a:p>
+        </p:txBody>
+      </p:sp>
+      <p:sp>
+        <p:nvSpPr>
+          <p:cNvPr id="56" name="Rectangle 55">
+            <a:extLst>
+              <a:ext uri="{FF2B5EF4-FFF2-40B4-BE49-F238E27FC236}">
+                <a16:creationId xmlns:a16="http://schemas.microsoft.com/office/drawing/2014/main" id="{7884E29B-A264-C951-B247-814E317D668F}"/>
+              </a:ext>
+            </a:extLst>
+          </p:cNvPr>
+          <p:cNvSpPr/>
+          <p:nvPr/>
+        </p:nvSpPr>
+        <p:spPr>
+          <a:xfrm>
+            <a:off x="3044006" y="3784279"/>
+            <a:ext cx="2574000" cy="162000"/>
+          </a:xfrm>
+          <a:prstGeom prst="rect">
+            <a:avLst/>
+          </a:prstGeom>
+        </p:spPr>
+        <p:style>
+          <a:lnRef idx="2">
+            <a:schemeClr val="accent3">
+              <a:shade val="15000"/>
+            </a:schemeClr>
+          </a:lnRef>
+          <a:fillRef idx="1">
+            <a:schemeClr val="accent3"/>
+          </a:fillRef>
+          <a:effectRef idx="0">
+            <a:schemeClr val="accent3"/>
+          </a:effectRef>
+          <a:fontRef idx="minor">
+            <a:schemeClr val="lt1"/>
+          </a:fontRef>
+        </p:style>
+        <p:txBody>
+          <a:bodyPr rtlCol="0" anchor="ctr"/>
+          <a:lstStyle/>
+          <a:p>
+            <a:pPr algn="ctr"/>
+            <a:r>
+              <a:rPr lang="en-US" sz="1400" dirty="0"/>
+              <a:t>SbSe = 22.6 nm</a:t>
+            </a:r>
+            <a:endParaRPr lang="en-GB" sz="1400" dirty="0"/>
+          </a:p>
+        </p:txBody>
+      </p:sp>
+      <p:sp>
+        <p:nvSpPr>
+          <p:cNvPr id="57" name="Rectangle 56">
+            <a:extLst>
+              <a:ext uri="{FF2B5EF4-FFF2-40B4-BE49-F238E27FC236}">
+                <a16:creationId xmlns:a16="http://schemas.microsoft.com/office/drawing/2014/main" id="{16C14BA8-D050-182D-67BA-1EC5DACEA245}"/>
+              </a:ext>
+            </a:extLst>
+          </p:cNvPr>
+          <p:cNvSpPr/>
+          <p:nvPr/>
+        </p:nvSpPr>
+        <p:spPr>
+          <a:xfrm>
+            <a:off x="3044460" y="3408899"/>
+            <a:ext cx="2573546" cy="367200"/>
+          </a:xfrm>
+          <a:prstGeom prst="rect">
+            <a:avLst/>
+          </a:prstGeom>
+        </p:spPr>
+        <p:style>
+          <a:lnRef idx="1">
+            <a:schemeClr val="accent4"/>
+          </a:lnRef>
+          <a:fillRef idx="2">
+            <a:schemeClr val="accent4"/>
+          </a:fillRef>
+          <a:effectRef idx="1">
+            <a:schemeClr val="accent4"/>
+          </a:effectRef>
+          <a:fontRef idx="minor">
+            <a:schemeClr val="dk1"/>
+          </a:fontRef>
+        </p:style>
+        <p:txBody>
+          <a:bodyPr rtlCol="0" anchor="ctr"/>
+          <a:lstStyle/>
+          <a:p>
+            <a:pPr algn="ctr"/>
+            <a:r>
+              <a:rPr lang="en-US" sz="1400" dirty="0"/>
+              <a:t>TiO2 = 56.6 nm</a:t>
+            </a:r>
+            <a:endParaRPr lang="en-GB" sz="1400" dirty="0"/>
+          </a:p>
+        </p:txBody>
+      </p:sp>
+      <p:sp>
+        <p:nvSpPr>
+          <p:cNvPr id="58" name="TextBox 57">
+            <a:extLst>
+              <a:ext uri="{FF2B5EF4-FFF2-40B4-BE49-F238E27FC236}">
+                <a16:creationId xmlns:a16="http://schemas.microsoft.com/office/drawing/2014/main" id="{468C66B1-4F22-7406-405D-E53D09BF8B19}"/>
+              </a:ext>
+            </a:extLst>
+          </p:cNvPr>
+          <p:cNvSpPr txBox="1"/>
+          <p:nvPr/>
+        </p:nvSpPr>
+        <p:spPr>
+          <a:xfrm>
+            <a:off x="9087157" y="901086"/>
+            <a:ext cx="2710486" cy="923330"/>
+          </a:xfrm>
+          <a:prstGeom prst="rect">
+            <a:avLst/>
+          </a:prstGeom>
+          <a:noFill/>
+        </p:spPr>
+        <p:txBody>
+          <a:bodyPr wrap="none" rtlCol="0">
+            <a:spAutoFit/>
+          </a:bodyPr>
+          <a:lstStyle/>
+          <a:p>
+            <a:r>
+              <a:rPr lang="en-US" b="1" dirty="0"/>
+              <a:t>Fabry-Perot </a:t>
+            </a:r>
+          </a:p>
+          <a:p>
+            <a:r>
+              <a:rPr lang="en-US" dirty="0"/>
+              <a:t>N=1(SbSe/TiO/SbSe) M=0</a:t>
+            </a:r>
+          </a:p>
+          <a:p>
+            <a:r>
+              <a:rPr lang="en-US" dirty="0"/>
+              <a:t>H = TiO2, L = MgF2</a:t>
+            </a:r>
+            <a:endParaRPr lang="en-GB" dirty="0"/>
+          </a:p>
+        </p:txBody>
+      </p:sp>
+    </p:spTree>
+    <p:extLst>
+      <p:ext uri="{BB962C8B-B14F-4D97-AF65-F5344CB8AC3E}">
+        <p14:creationId xmlns:p14="http://schemas.microsoft.com/office/powerpoint/2010/main" val="4084253559"/>
+      </p:ext>
+    </p:extLst>
+  </p:cSld>
+  <p:clrMapOvr>
+    <a:masterClrMapping/>
+  </p:clrMapOvr>
+</p:sld>
+</file>
+
+<file path=ppt/slides/slide26.xml><?xml version="1.0" encoding="utf-8"?>
+<p:sld xmlns:a="http://schemas.openxmlformats.org/drawingml/2006/main" xmlns:r="http://schemas.openxmlformats.org/officeDocument/2006/relationships" xmlns:p="http://schemas.openxmlformats.org/presentationml/2006/main">
+  <p:cSld>
+    <p:spTree>
+      <p:nvGrpSpPr>
+        <p:cNvPr id="1" name="">
+          <a:extLst>
+            <a:ext uri="{FF2B5EF4-FFF2-40B4-BE49-F238E27FC236}">
+              <a16:creationId xmlns:a16="http://schemas.microsoft.com/office/drawing/2014/main" id="{4BAF56AE-BCFE-50FA-2893-6F35E2A5D282}"/>
+            </a:ext>
+          </a:extLst>
+        </p:cNvPr>
+        <p:cNvGrpSpPr/>
+        <p:nvPr/>
+      </p:nvGrpSpPr>
+      <p:grpSpPr>
+        <a:xfrm>
+          <a:off x="0" y="0"/>
+          <a:ext cx="0" cy="0"/>
+          <a:chOff x="0" y="0"/>
+          <a:chExt cx="0" cy="0"/>
+        </a:xfrm>
+      </p:grpSpPr>
+      <p:sp>
+        <p:nvSpPr>
+          <p:cNvPr id="2" name="Title 1">
+            <a:extLst>
+              <a:ext uri="{FF2B5EF4-FFF2-40B4-BE49-F238E27FC236}">
+                <a16:creationId xmlns:a16="http://schemas.microsoft.com/office/drawing/2014/main" id="{88787E33-E6E4-5761-B297-7057BFEB6354}"/>
+              </a:ext>
+            </a:extLst>
+          </p:cNvPr>
+          <p:cNvSpPr>
+            <a:spLocks noGrp="1"/>
+          </p:cNvSpPr>
+          <p:nvPr>
+            <p:ph type="title"/>
+          </p:nvPr>
+        </p:nvSpPr>
+        <p:spPr>
+          <a:xfrm>
+            <a:off x="242978" y="365126"/>
+            <a:ext cx="5588479" cy="892774"/>
+          </a:xfrm>
+          <a:solidFill>
+            <a:srgbClr val="C00000"/>
+          </a:solidFill>
+        </p:spPr>
+        <p:txBody>
+          <a:bodyPr/>
+          <a:lstStyle/>
+          <a:p>
+            <a:r>
+              <a:rPr lang="en-US" dirty="0"/>
+              <a:t>1064 nm Optical limiter</a:t>
+            </a:r>
+            <a:endParaRPr lang="en-GB" dirty="0"/>
+          </a:p>
+        </p:txBody>
+      </p:sp>
+      <p:sp>
+        <p:nvSpPr>
+          <p:cNvPr id="3" name="TextBox 2">
+            <a:extLst>
+              <a:ext uri="{FF2B5EF4-FFF2-40B4-BE49-F238E27FC236}">
+                <a16:creationId xmlns:a16="http://schemas.microsoft.com/office/drawing/2014/main" id="{353AE2FF-A6D0-CF83-13B9-4E39E217757D}"/>
+              </a:ext>
+            </a:extLst>
+          </p:cNvPr>
+          <p:cNvSpPr txBox="1"/>
+          <p:nvPr/>
+        </p:nvSpPr>
+        <p:spPr>
+          <a:xfrm>
+            <a:off x="242978" y="1514475"/>
+            <a:ext cx="5853022" cy="2862322"/>
+          </a:xfrm>
+          <a:prstGeom prst="rect">
+            <a:avLst/>
+          </a:prstGeom>
+          <a:noFill/>
+        </p:spPr>
+        <p:txBody>
+          <a:bodyPr wrap="square" rtlCol="0">
+            <a:spAutoFit/>
+          </a:bodyPr>
+          <a:lstStyle/>
+          <a:p>
+            <a:r>
+              <a:rPr lang="en-US" sz="3000" b="1" dirty="0"/>
+              <a:t>Endurance simulation</a:t>
+            </a:r>
+          </a:p>
+          <a:p>
+            <a:pPr marL="342900" indent="-342900">
+              <a:buAutoNum type="arabicPeriod"/>
+            </a:pPr>
+            <a:r>
+              <a:rPr lang="en-US" sz="3000" dirty="0"/>
+              <a:t>Single-layer design (HWOT)</a:t>
+            </a:r>
+          </a:p>
+          <a:p>
+            <a:pPr marL="342900" indent="-342900">
+              <a:buAutoNum type="arabicPeriod"/>
+            </a:pPr>
+            <a:r>
+              <a:rPr lang="en-US" sz="3000" dirty="0"/>
+              <a:t>Two-layer design (QWOT)</a:t>
+            </a:r>
+          </a:p>
+          <a:p>
+            <a:pPr marL="342900" indent="-342900">
+              <a:buFontTx/>
+              <a:buAutoNum type="arabicPeriod"/>
+            </a:pPr>
+            <a:r>
+              <a:rPr lang="en-US" sz="3000" dirty="0"/>
+              <a:t>Edge-filter design (N=3)</a:t>
+            </a:r>
+          </a:p>
+          <a:p>
+            <a:pPr marL="342900" indent="-342900">
+              <a:buFontTx/>
+              <a:buAutoNum type="arabicPeriod"/>
+            </a:pPr>
+            <a:r>
+              <a:rPr lang="th-TH" sz="3000" dirty="0"/>
+              <a:t>*ถ้ามีเวลา</a:t>
+            </a:r>
+            <a:r>
+              <a:rPr lang="en-US" sz="3000" dirty="0"/>
+              <a:t> Edge-filter design (</a:t>
+            </a:r>
+            <a:r>
+              <a:rPr lang="en-US" sz="3000" dirty="0">
+                <a:cs typeface="Arial" panose="020B0604020202020204" pitchFamily="34" charset="0"/>
+              </a:rPr>
+              <a:t>N=1, 5, 8</a:t>
+            </a:r>
+            <a:r>
+              <a:rPr lang="en-US" sz="3000" dirty="0"/>
+              <a:t>)</a:t>
+            </a:r>
+          </a:p>
+        </p:txBody>
+      </p:sp>
+      <p:sp>
+        <p:nvSpPr>
+          <p:cNvPr id="4" name="Title 1">
+            <a:extLst>
+              <a:ext uri="{FF2B5EF4-FFF2-40B4-BE49-F238E27FC236}">
+                <a16:creationId xmlns:a16="http://schemas.microsoft.com/office/drawing/2014/main" id="{3893F11F-2BFC-978D-40AD-34B7DB5CD433}"/>
+              </a:ext>
+            </a:extLst>
+          </p:cNvPr>
+          <p:cNvSpPr txBox="1">
+            <a:spLocks/>
+          </p:cNvSpPr>
+          <p:nvPr/>
+        </p:nvSpPr>
+        <p:spPr>
+          <a:xfrm>
+            <a:off x="6360545" y="365126"/>
+            <a:ext cx="5587200" cy="892774"/>
+          </a:xfrm>
+          <a:prstGeom prst="rect">
+            <a:avLst/>
+          </a:prstGeom>
+          <a:solidFill>
+            <a:schemeClr val="accent6"/>
+          </a:solidFill>
+        </p:spPr>
+        <p:txBody>
+          <a:bodyPr vert="horz" lIns="91440" tIns="45720" rIns="91440" bIns="45720" rtlCol="0" anchor="ctr">
+            <a:normAutofit/>
+          </a:bodyPr>
+          <a:lstStyle>
+            <a:lvl1pPr algn="l" defTabSz="914400" rtl="0" eaLnBrk="1" latinLnBrk="0" hangingPunct="1">
+              <a:lnSpc>
+                <a:spcPct val="90000"/>
+              </a:lnSpc>
+              <a:spcBef>
+                <a:spcPct val="0"/>
+              </a:spcBef>
+              <a:buNone/>
+              <a:defRPr sz="4400" kern="1200">
+                <a:solidFill>
+                  <a:schemeClr val="tx1"/>
+                </a:solidFill>
+                <a:latin typeface="+mj-lt"/>
+                <a:ea typeface="+mj-ea"/>
+                <a:cs typeface="+mj-cs"/>
+              </a:defRPr>
+            </a:lvl1pPr>
+          </a:lstStyle>
+          <a:p>
+            <a:r>
+              <a:rPr lang="en-US" dirty="0"/>
+              <a:t>532 nm Optical limiter</a:t>
+            </a:r>
+            <a:endParaRPr lang="en-GB" dirty="0"/>
+          </a:p>
+        </p:txBody>
+      </p:sp>
+      <p:sp>
+        <p:nvSpPr>
+          <p:cNvPr id="6" name="TextBox 5">
+            <a:extLst>
+              <a:ext uri="{FF2B5EF4-FFF2-40B4-BE49-F238E27FC236}">
+                <a16:creationId xmlns:a16="http://schemas.microsoft.com/office/drawing/2014/main" id="{B4BC6A22-6A2E-53C7-98AE-5A14E8CB1B39}"/>
+              </a:ext>
+            </a:extLst>
+          </p:cNvPr>
+          <p:cNvSpPr txBox="1"/>
+          <p:nvPr/>
+        </p:nvSpPr>
+        <p:spPr>
+          <a:xfrm>
+            <a:off x="6360545" y="1514475"/>
+            <a:ext cx="6142066" cy="1938992"/>
+          </a:xfrm>
+          <a:prstGeom prst="rect">
+            <a:avLst/>
+          </a:prstGeom>
+          <a:noFill/>
+        </p:spPr>
+        <p:txBody>
+          <a:bodyPr wrap="none" rtlCol="0">
+            <a:spAutoFit/>
+          </a:bodyPr>
+          <a:lstStyle/>
+          <a:p>
+            <a:r>
+              <a:rPr lang="en-US" sz="3000" b="1" dirty="0"/>
+              <a:t>Endurance simulation</a:t>
+            </a:r>
+          </a:p>
+          <a:p>
+            <a:pPr marL="514350" indent="-514350">
+              <a:buAutoNum type="arabicPeriod"/>
+            </a:pPr>
+            <a:r>
+              <a:rPr lang="en-US" sz="3000" b="1" dirty="0"/>
+              <a:t>Single-layer</a:t>
+            </a:r>
+          </a:p>
+          <a:p>
+            <a:pPr marL="514350" indent="-514350">
+              <a:buAutoNum type="arabicPeriod"/>
+            </a:pPr>
+            <a:r>
+              <a:rPr lang="en-US" sz="3000" b="1" dirty="0"/>
+              <a:t>Two-layer (non QWOT)</a:t>
+            </a:r>
+          </a:p>
+          <a:p>
+            <a:pPr marL="514350" indent="-514350">
+              <a:buAutoNum type="arabicPeriod"/>
+            </a:pPr>
+            <a:r>
+              <a:rPr lang="en-US" sz="3000" b="1" dirty="0"/>
+              <a:t>Fabry-Perot: </a:t>
+            </a:r>
+            <a:r>
+              <a:rPr lang="en-US" sz="3000" dirty="0"/>
+              <a:t>N1 (MgF/SbSe) M0</a:t>
+            </a:r>
+          </a:p>
+        </p:txBody>
+      </p:sp>
+    </p:spTree>
+    <p:extLst>
+      <p:ext uri="{BB962C8B-B14F-4D97-AF65-F5344CB8AC3E}">
+        <p14:creationId xmlns:p14="http://schemas.microsoft.com/office/powerpoint/2010/main" val="2856282081"/>
       </p:ext>
     </p:extLst>
   </p:cSld>

</xml_diff>

<commit_message>
Add revised endurance simulation
</commit_message>
<xml_diff>
--- a/meetings/Meeting PP.pptx
+++ b/meetings/Meeting PP.pptx
@@ -31,6 +31,8 @@
     <p:sldId id="313" r:id="rId25"/>
     <p:sldId id="311" r:id="rId26"/>
     <p:sldId id="312" r:id="rId27"/>
+    <p:sldId id="314" r:id="rId28"/>
+    <p:sldId id="315" r:id="rId29"/>
   </p:sldIdLst>
   <p:sldSz cx="12192000" cy="6858000"/>
   <p:notesSz cx="6858000" cy="9144000"/>
@@ -286,7 +288,7 @@
           <a:p>
             <a:fld id="{AC95DD63-6668-4FD6-91E0-C37FAC7BA147}" type="datetimeFigureOut">
               <a:rPr lang="en-GB" smtClean="0"/>
-              <a:t>18/05/2026</a:t>
+              <a:t>01/07/2026</a:t>
             </a:fld>
             <a:endParaRPr lang="en-GB"/>
           </a:p>
@@ -486,7 +488,7 @@
           <a:p>
             <a:fld id="{AC95DD63-6668-4FD6-91E0-C37FAC7BA147}" type="datetimeFigureOut">
               <a:rPr lang="en-GB" smtClean="0"/>
-              <a:t>18/05/2026</a:t>
+              <a:t>01/07/2026</a:t>
             </a:fld>
             <a:endParaRPr lang="en-GB"/>
           </a:p>
@@ -696,7 +698,7 @@
           <a:p>
             <a:fld id="{AC95DD63-6668-4FD6-91E0-C37FAC7BA147}" type="datetimeFigureOut">
               <a:rPr lang="en-GB" smtClean="0"/>
-              <a:t>18/05/2026</a:t>
+              <a:t>01/07/2026</a:t>
             </a:fld>
             <a:endParaRPr lang="en-GB"/>
           </a:p>
@@ -896,7 +898,7 @@
           <a:p>
             <a:fld id="{AC95DD63-6668-4FD6-91E0-C37FAC7BA147}" type="datetimeFigureOut">
               <a:rPr lang="en-GB" smtClean="0"/>
-              <a:t>18/05/2026</a:t>
+              <a:t>01/07/2026</a:t>
             </a:fld>
             <a:endParaRPr lang="en-GB"/>
           </a:p>
@@ -1172,7 +1174,7 @@
           <a:p>
             <a:fld id="{AC95DD63-6668-4FD6-91E0-C37FAC7BA147}" type="datetimeFigureOut">
               <a:rPr lang="en-GB" smtClean="0"/>
-              <a:t>18/05/2026</a:t>
+              <a:t>01/07/2026</a:t>
             </a:fld>
             <a:endParaRPr lang="en-GB"/>
           </a:p>
@@ -1440,7 +1442,7 @@
           <a:p>
             <a:fld id="{AC95DD63-6668-4FD6-91E0-C37FAC7BA147}" type="datetimeFigureOut">
               <a:rPr lang="en-GB" smtClean="0"/>
-              <a:t>18/05/2026</a:t>
+              <a:t>01/07/2026</a:t>
             </a:fld>
             <a:endParaRPr lang="en-GB"/>
           </a:p>
@@ -1855,7 +1857,7 @@
           <a:p>
             <a:fld id="{AC95DD63-6668-4FD6-91E0-C37FAC7BA147}" type="datetimeFigureOut">
               <a:rPr lang="en-GB" smtClean="0"/>
-              <a:t>18/05/2026</a:t>
+              <a:t>01/07/2026</a:t>
             </a:fld>
             <a:endParaRPr lang="en-GB"/>
           </a:p>
@@ -1997,7 +1999,7 @@
           <a:p>
             <a:fld id="{AC95DD63-6668-4FD6-91E0-C37FAC7BA147}" type="datetimeFigureOut">
               <a:rPr lang="en-GB" smtClean="0"/>
-              <a:t>18/05/2026</a:t>
+              <a:t>01/07/2026</a:t>
             </a:fld>
             <a:endParaRPr lang="en-GB"/>
           </a:p>
@@ -2110,7 +2112,7 @@
           <a:p>
             <a:fld id="{AC95DD63-6668-4FD6-91E0-C37FAC7BA147}" type="datetimeFigureOut">
               <a:rPr lang="en-GB" smtClean="0"/>
-              <a:t>18/05/2026</a:t>
+              <a:t>01/07/2026</a:t>
             </a:fld>
             <a:endParaRPr lang="en-GB"/>
           </a:p>
@@ -2423,7 +2425,7 @@
           <a:p>
             <a:fld id="{AC95DD63-6668-4FD6-91E0-C37FAC7BA147}" type="datetimeFigureOut">
               <a:rPr lang="en-GB" smtClean="0"/>
-              <a:t>18/05/2026</a:t>
+              <a:t>01/07/2026</a:t>
             </a:fld>
             <a:endParaRPr lang="en-GB"/>
           </a:p>
@@ -2712,7 +2714,7 @@
           <a:p>
             <a:fld id="{AC95DD63-6668-4FD6-91E0-C37FAC7BA147}" type="datetimeFigureOut">
               <a:rPr lang="en-GB" smtClean="0"/>
-              <a:t>18/05/2026</a:t>
+              <a:t>01/07/2026</a:t>
             </a:fld>
             <a:endParaRPr lang="en-GB"/>
           </a:p>
@@ -2955,7 +2957,7 @@
           <a:p>
             <a:fld id="{AC95DD63-6668-4FD6-91E0-C37FAC7BA147}" type="datetimeFigureOut">
               <a:rPr lang="en-GB" smtClean="0"/>
-              <a:t>18/05/2026</a:t>
+              <a:t>01/07/2026</a:t>
             </a:fld>
             <a:endParaRPr lang="en-GB"/>
           </a:p>
@@ -10959,6 +10961,374 @@
     <p:extLst>
       <p:ext uri="{BB962C8B-B14F-4D97-AF65-F5344CB8AC3E}">
         <p14:creationId xmlns:p14="http://schemas.microsoft.com/office/powerpoint/2010/main" val="2856282081"/>
+      </p:ext>
+    </p:extLst>
+  </p:cSld>
+  <p:clrMapOvr>
+    <a:masterClrMapping/>
+  </p:clrMapOvr>
+</p:sld>
+</file>
+
+<file path=ppt/slides/slide27.xml><?xml version="1.0" encoding="utf-8"?>
+<p:sld xmlns:a="http://schemas.openxmlformats.org/drawingml/2006/main" xmlns:r="http://schemas.openxmlformats.org/officeDocument/2006/relationships" xmlns:p="http://schemas.openxmlformats.org/presentationml/2006/main">
+  <p:cSld>
+    <p:spTree>
+      <p:nvGrpSpPr>
+        <p:cNvPr id="1" name=""/>
+        <p:cNvGrpSpPr/>
+        <p:nvPr/>
+      </p:nvGrpSpPr>
+      <p:grpSpPr>
+        <a:xfrm>
+          <a:off x="0" y="0"/>
+          <a:ext cx="0" cy="0"/>
+          <a:chOff x="0" y="0"/>
+          <a:chExt cx="0" cy="0"/>
+        </a:xfrm>
+      </p:grpSpPr>
+      <p:pic>
+        <p:nvPicPr>
+          <p:cNvPr id="5" name="Picture 4">
+            <a:extLst>
+              <a:ext uri="{FF2B5EF4-FFF2-40B4-BE49-F238E27FC236}">
+                <a16:creationId xmlns:a16="http://schemas.microsoft.com/office/drawing/2014/main" id="{6C92F186-E1D4-A70A-AF7E-9E84513383C9}"/>
+              </a:ext>
+            </a:extLst>
+          </p:cNvPr>
+          <p:cNvPicPr>
+            <a:picLocks noChangeAspect="1"/>
+          </p:cNvPicPr>
+          <p:nvPr/>
+        </p:nvPicPr>
+        <p:blipFill>
+          <a:blip r:embed="rId2"/>
+          <a:stretch>
+            <a:fillRect/>
+          </a:stretch>
+        </p:blipFill>
+        <p:spPr>
+          <a:xfrm>
+            <a:off x="177800" y="0"/>
+            <a:ext cx="11836400" cy="6858000"/>
+          </a:xfrm>
+          <a:prstGeom prst="rect">
+            <a:avLst/>
+          </a:prstGeom>
+        </p:spPr>
+      </p:pic>
+      <p:pic>
+        <p:nvPicPr>
+          <p:cNvPr id="7" name="Picture 6">
+            <a:extLst>
+              <a:ext uri="{FF2B5EF4-FFF2-40B4-BE49-F238E27FC236}">
+                <a16:creationId xmlns:a16="http://schemas.microsoft.com/office/drawing/2014/main" id="{587E47AC-082C-72EF-0152-D6DD7DBE47D6}"/>
+              </a:ext>
+            </a:extLst>
+          </p:cNvPr>
+          <p:cNvPicPr>
+            <a:picLocks noChangeAspect="1"/>
+          </p:cNvPicPr>
+          <p:nvPr/>
+        </p:nvPicPr>
+        <p:blipFill>
+          <a:blip r:embed="rId3">
+            <a:alphaModFix amt="50000"/>
+          </a:blip>
+          <a:srcRect t="37862"/>
+          <a:stretch>
+            <a:fillRect/>
+          </a:stretch>
+        </p:blipFill>
+        <p:spPr>
+          <a:xfrm>
+            <a:off x="177800" y="2596550"/>
+            <a:ext cx="11836400" cy="4261449"/>
+          </a:xfrm>
+          <a:prstGeom prst="rect">
+            <a:avLst/>
+          </a:prstGeom>
+        </p:spPr>
+      </p:pic>
+      <p:sp>
+        <p:nvSpPr>
+          <p:cNvPr id="8" name="TextBox 7">
+            <a:extLst>
+              <a:ext uri="{FF2B5EF4-FFF2-40B4-BE49-F238E27FC236}">
+                <a16:creationId xmlns:a16="http://schemas.microsoft.com/office/drawing/2014/main" id="{09E3E62E-DD0E-AC9D-F5EE-998A72DFD39A}"/>
+              </a:ext>
+            </a:extLst>
+          </p:cNvPr>
+          <p:cNvSpPr txBox="1"/>
+          <p:nvPr/>
+        </p:nvSpPr>
+        <p:spPr>
+          <a:xfrm>
+            <a:off x="8773064" y="1121434"/>
+            <a:ext cx="1904689" cy="646331"/>
+          </a:xfrm>
+          <a:prstGeom prst="rect">
+            <a:avLst/>
+          </a:prstGeom>
+          <a:noFill/>
+        </p:spPr>
+        <p:txBody>
+          <a:bodyPr wrap="none" rtlCol="0">
+            <a:spAutoFit/>
+          </a:bodyPr>
+          <a:lstStyle/>
+          <a:p>
+            <a:r>
+              <a:rPr lang="en-US" dirty="0">
+                <a:solidFill>
+                  <a:schemeClr val="accent1"/>
+                </a:solidFill>
+              </a:rPr>
+              <a:t>T(amo)	= 93.8%</a:t>
+            </a:r>
+          </a:p>
+          <a:p>
+            <a:r>
+              <a:rPr lang="en-US" dirty="0">
+                <a:solidFill>
+                  <a:srgbClr val="FF0000"/>
+                </a:solidFill>
+              </a:rPr>
+              <a:t>T(cry)	= 0.9%</a:t>
+            </a:r>
+            <a:endParaRPr lang="en-GB" dirty="0">
+              <a:solidFill>
+                <a:srgbClr val="FF0000"/>
+              </a:solidFill>
+            </a:endParaRPr>
+          </a:p>
+        </p:txBody>
+      </p:sp>
+      <p:sp>
+        <p:nvSpPr>
+          <p:cNvPr id="9" name="TextBox 8">
+            <a:extLst>
+              <a:ext uri="{FF2B5EF4-FFF2-40B4-BE49-F238E27FC236}">
+                <a16:creationId xmlns:a16="http://schemas.microsoft.com/office/drawing/2014/main" id="{EDA2E163-06A8-CE27-2209-D3F4C4E96593}"/>
+              </a:ext>
+            </a:extLst>
+          </p:cNvPr>
+          <p:cNvSpPr txBox="1"/>
+          <p:nvPr/>
+        </p:nvSpPr>
+        <p:spPr>
+          <a:xfrm>
+            <a:off x="8721254" y="828136"/>
+            <a:ext cx="2008307" cy="369332"/>
+          </a:xfrm>
+          <a:prstGeom prst="rect">
+            <a:avLst/>
+          </a:prstGeom>
+          <a:noFill/>
+        </p:spPr>
+        <p:txBody>
+          <a:bodyPr wrap="none" rtlCol="0">
+            <a:spAutoFit/>
+          </a:bodyPr>
+          <a:lstStyle/>
+          <a:p>
+            <a:pPr algn="ctr"/>
+            <a:r>
+              <a:rPr lang="en-US" b="1" dirty="0"/>
+              <a:t>9-layer edge filter</a:t>
+            </a:r>
+            <a:endParaRPr lang="en-GB" b="1" dirty="0"/>
+          </a:p>
+        </p:txBody>
+      </p:sp>
+    </p:spTree>
+    <p:extLst>
+      <p:ext uri="{BB962C8B-B14F-4D97-AF65-F5344CB8AC3E}">
+        <p14:creationId xmlns:p14="http://schemas.microsoft.com/office/powerpoint/2010/main" val="2580020288"/>
+      </p:ext>
+    </p:extLst>
+  </p:cSld>
+  <p:clrMapOvr>
+    <a:masterClrMapping/>
+  </p:clrMapOvr>
+</p:sld>
+</file>
+
+<file path=ppt/slides/slide28.xml><?xml version="1.0" encoding="utf-8"?>
+<p:sld xmlns:a="http://schemas.openxmlformats.org/drawingml/2006/main" xmlns:r="http://schemas.openxmlformats.org/officeDocument/2006/relationships" xmlns:p="http://schemas.openxmlformats.org/presentationml/2006/main">
+  <p:cSld>
+    <p:spTree>
+      <p:nvGrpSpPr>
+        <p:cNvPr id="1" name=""/>
+        <p:cNvGrpSpPr/>
+        <p:nvPr/>
+      </p:nvGrpSpPr>
+      <p:grpSpPr>
+        <a:xfrm>
+          <a:off x="0" y="0"/>
+          <a:ext cx="0" cy="0"/>
+          <a:chOff x="0" y="0"/>
+          <a:chExt cx="0" cy="0"/>
+        </a:xfrm>
+      </p:grpSpPr>
+      <p:pic>
+        <p:nvPicPr>
+          <p:cNvPr id="10" name="Picture 9">
+            <a:extLst>
+              <a:ext uri="{FF2B5EF4-FFF2-40B4-BE49-F238E27FC236}">
+                <a16:creationId xmlns:a16="http://schemas.microsoft.com/office/drawing/2014/main" id="{E2B00B04-05FC-FA96-283B-C23983A259FD}"/>
+              </a:ext>
+            </a:extLst>
+          </p:cNvPr>
+          <p:cNvPicPr>
+            <a:picLocks noChangeAspect="1"/>
+          </p:cNvPicPr>
+          <p:nvPr/>
+        </p:nvPicPr>
+        <p:blipFill>
+          <a:blip r:embed="rId2"/>
+          <a:stretch>
+            <a:fillRect/>
+          </a:stretch>
+        </p:blipFill>
+        <p:spPr>
+          <a:xfrm>
+            <a:off x="177800" y="0"/>
+            <a:ext cx="11836400" cy="6858000"/>
+          </a:xfrm>
+          <a:prstGeom prst="rect">
+            <a:avLst/>
+          </a:prstGeom>
+        </p:spPr>
+      </p:pic>
+      <p:pic>
+        <p:nvPicPr>
+          <p:cNvPr id="8" name="Picture 7">
+            <a:extLst>
+              <a:ext uri="{FF2B5EF4-FFF2-40B4-BE49-F238E27FC236}">
+                <a16:creationId xmlns:a16="http://schemas.microsoft.com/office/drawing/2014/main" id="{C5264605-C9C0-11DF-C1EA-B25BE31A2086}"/>
+              </a:ext>
+            </a:extLst>
+          </p:cNvPr>
+          <p:cNvPicPr>
+            <a:picLocks noChangeAspect="1"/>
+          </p:cNvPicPr>
+          <p:nvPr/>
+        </p:nvPicPr>
+        <p:blipFill>
+          <a:blip r:embed="rId3">
+            <a:alphaModFix amt="50000"/>
+          </a:blip>
+          <a:srcRect t="38240" b="-1"/>
+          <a:stretch>
+            <a:fillRect/>
+          </a:stretch>
+        </p:blipFill>
+        <p:spPr>
+          <a:xfrm>
+            <a:off x="177800" y="2622430"/>
+            <a:ext cx="11836400" cy="4235569"/>
+          </a:xfrm>
+          <a:prstGeom prst="rect">
+            <a:avLst/>
+          </a:prstGeom>
+        </p:spPr>
+      </p:pic>
+      <p:sp>
+        <p:nvSpPr>
+          <p:cNvPr id="4" name="TextBox 3">
+            <a:extLst>
+              <a:ext uri="{FF2B5EF4-FFF2-40B4-BE49-F238E27FC236}">
+                <a16:creationId xmlns:a16="http://schemas.microsoft.com/office/drawing/2014/main" id="{5AB4A808-DB06-7263-36C9-7F0ADFABA0EB}"/>
+              </a:ext>
+            </a:extLst>
+          </p:cNvPr>
+          <p:cNvSpPr txBox="1"/>
+          <p:nvPr/>
+        </p:nvSpPr>
+        <p:spPr>
+          <a:xfrm>
+            <a:off x="8773064" y="1121434"/>
+            <a:ext cx="1904689" cy="646331"/>
+          </a:xfrm>
+          <a:prstGeom prst="rect">
+            <a:avLst/>
+          </a:prstGeom>
+          <a:noFill/>
+        </p:spPr>
+        <p:txBody>
+          <a:bodyPr wrap="none" rtlCol="0">
+            <a:spAutoFit/>
+          </a:bodyPr>
+          <a:lstStyle/>
+          <a:p>
+            <a:r>
+              <a:rPr lang="en-US" dirty="0">
+                <a:solidFill>
+                  <a:schemeClr val="accent1"/>
+                </a:solidFill>
+              </a:rPr>
+              <a:t>T(amo)	= 93.6%</a:t>
+            </a:r>
+          </a:p>
+          <a:p>
+            <a:r>
+              <a:rPr lang="en-US" dirty="0">
+                <a:solidFill>
+                  <a:srgbClr val="FF0000"/>
+                </a:solidFill>
+              </a:rPr>
+              <a:t>T(cry)	= 0.21%</a:t>
+            </a:r>
+            <a:endParaRPr lang="en-GB" dirty="0">
+              <a:solidFill>
+                <a:srgbClr val="FF0000"/>
+              </a:solidFill>
+            </a:endParaRPr>
+          </a:p>
+        </p:txBody>
+      </p:sp>
+      <p:sp>
+        <p:nvSpPr>
+          <p:cNvPr id="11" name="TextBox 10">
+            <a:extLst>
+              <a:ext uri="{FF2B5EF4-FFF2-40B4-BE49-F238E27FC236}">
+                <a16:creationId xmlns:a16="http://schemas.microsoft.com/office/drawing/2014/main" id="{5E86CC82-AECD-BDD7-FAD1-26E1BA58DFD9}"/>
+              </a:ext>
+            </a:extLst>
+          </p:cNvPr>
+          <p:cNvSpPr txBox="1"/>
+          <p:nvPr/>
+        </p:nvSpPr>
+        <p:spPr>
+          <a:xfrm>
+            <a:off x="8659539" y="828136"/>
+            <a:ext cx="2131737" cy="369332"/>
+          </a:xfrm>
+          <a:prstGeom prst="rect">
+            <a:avLst/>
+          </a:prstGeom>
+          <a:noFill/>
+        </p:spPr>
+        <p:txBody>
+          <a:bodyPr wrap="none" rtlCol="0">
+            <a:spAutoFit/>
+          </a:bodyPr>
+          <a:lstStyle/>
+          <a:p>
+            <a:pPr algn="ctr"/>
+            <a:r>
+              <a:rPr lang="en-US" b="1" dirty="0"/>
+              <a:t>11-layer edge filter</a:t>
+            </a:r>
+            <a:endParaRPr lang="en-GB" b="1" dirty="0"/>
+          </a:p>
+        </p:txBody>
+      </p:sp>
+    </p:spTree>
+    <p:extLst>
+      <p:ext uri="{BB962C8B-B14F-4D97-AF65-F5344CB8AC3E}">
+        <p14:creationId xmlns:p14="http://schemas.microsoft.com/office/powerpoint/2010/main" val="2493845953"/>
       </p:ext>
     </p:extLst>
   </p:cSld>

</xml_diff>